<commit_message>
Restyle deck to white/dark gray/navy; add default design rules
Co-Authored-By: Claude Sonnet 5.5 <noreply@anthropic.com>
Claude-Session: https://claude.ai/code/session_017WPoaJyboL7hHVgWMjXgCi
</commit_message>
<xml_diff>
--- a/dbj_it_shindan_proposal.pptx
+++ b/dbj_it_shindan_proposal.pptx
@@ -117,31 +117,31 @@
   <p:extLst>
     <p:ext uri="{521415D9-36F7-43E2-AB2F-B90AF26B5E84}">
       <p14:sectionLst xmlns:p14="http://schemas.microsoft.com/office/powerpoint/2010/main">
-        <p14:section name="導入" id="{6fc3e761-cd2b-526e-850e-4043932c30f5}">
+        <p14:section name="導入" id="{5b5dd43f-7386-0bca-7c2e-f9ecd7508ab8}">
           <p14:sldIdLst>
             <p14:sldId id="256"/>
           </p14:sldIdLst>
         </p14:section>
-        <p14:section name="狙いと全体像" id="{b38afeb7-b4bc-db6d-a54a-b2d942a78075}">
+        <p14:section name="狙いと全体像" id="{988229a7-37aa-a072-0233-39cfb54a0953}">
           <p14:sldIdLst>
             <p14:sldId id="257"/>
             <p14:sldId id="258"/>
             <p14:sldId id="259"/>
           </p14:sldIdLst>
         </p14:section>
-        <p14:section name="ホワイトペーパー" id="{e33afc20-6ac9-aacf-8baa-b87a55fd5048}">
+        <p14:section name="ホワイトペーパー" id="{0e813fab-c796-ab17-6f08-d560cc924c90}">
           <p14:sldIdLst>
             <p14:sldId id="260"/>
             <p14:sldId id="261"/>
             <p14:sldId id="262"/>
           </p14:sldIdLst>
         </p14:section>
-        <p14:section name="流入コラム" id="{798a9742-0c9d-3051-40ad-50b4fe0fd66d}">
+        <p14:section name="流入コラム" id="{68d6149b-3ca0-41bc-3c00-2de65ab1dfc8}">
           <p14:sldIdLst>
             <p14:sldId id="263"/>
           </p14:sldIdLst>
         </p14:section>
-        <p14:section name="進め方" id="{3aa98321-a7e8-86aa-7817-0ab45ac375e9}">
+        <p14:section name="進め方" id="{bb65ad8d-19da-1e64-2e6d-63d575ba9fc7}">
           <p14:sldIdLst>
             <p14:sldId id="264"/>
             <p14:sldId id="265"/>
@@ -1510,7 +1510,7 @@
     <p:bg>
       <p:bgPr>
         <a:solidFill>
-          <a:srgbClr val="0B4F5C"/>
+          <a:srgbClr val="FFFFFF"/>
         </a:solidFill>
       </p:bgPr>
     </p:bg>
@@ -2017,7 +2017,7 @@
             <a:r>
               <a:rPr lang="en-US" sz="1400" b="1" spc="400" kern="0" dirty="0">
                 <a:solidFill>
-                  <a:schemeClr val="accent6"/>
+                  <a:schemeClr val="accent1"/>
                 </a:solidFill>
               </a:rPr>
               <a:t>CONTENT MARKETING PROPOSAL</a:t>
@@ -2053,7 +2053,7 @@
             <a:r>
               <a:rPr lang="en-US" sz="4000" b="1" dirty="0">
                 <a:solidFill>
-                  <a:schemeClr val="bg1"/>
+                  <a:schemeClr val="tx1"/>
                 </a:solidFill>
               </a:rPr>
               <a:t>IT診断サービスの訴求に向けた</a:t>
@@ -2067,7 +2067,7 @@
             <a:r>
               <a:rPr lang="en-US" sz="4000" b="1" dirty="0">
                 <a:solidFill>
-                  <a:schemeClr val="bg1"/>
+                  <a:schemeClr val="tx1"/>
                 </a:solidFill>
               </a:rPr>
               <a:t>コンテンツ施策のご提案</a:t>
@@ -2103,7 +2103,7 @@
             <a:r>
               <a:rPr lang="en-US" sz="1800" dirty="0">
                 <a:solidFill>
-                  <a:schemeClr val="accent6"/>
+                  <a:schemeClr val="accent5"/>
                 </a:solidFill>
               </a:rPr>
               <a:t>経営層向け「IT健康診断」チェックリスト（ホワイトペーパー）と、</a:t>
@@ -2117,7 +2117,7 @@
             <a:r>
               <a:rPr lang="en-US" sz="1800" dirty="0">
                 <a:solidFill>
-                  <a:schemeClr val="accent6"/>
+                  <a:schemeClr val="accent5"/>
                 </a:solidFill>
               </a:rPr>
               <a:t>流入元となるコラム群の設計案</a:t>
@@ -2153,7 +2153,7 @@
             <a:r>
               <a:rPr lang="en-US" sz="1400" dirty="0">
                 <a:solidFill>
-                  <a:schemeClr val="bg1"/>
+                  <a:schemeClr val="tx1"/>
                 </a:solidFill>
               </a:rPr>
               <a:t>ご提案資料（案）　2026年10月</a:t>
@@ -2214,7 +2214,7 @@
             <a:r>
               <a:rPr lang="en-US" sz="2800" b="1" dirty="0">
                 <a:solidFill>
-                  <a:schemeClr val="tx2"/>
+                  <a:schemeClr val="tx1"/>
                 </a:solidFill>
               </a:rPr>
               <a:t>営業での活用と、見るべき指標</a:t>
@@ -2773,7 +2773,7 @@
             <a:r>
               <a:rPr lang="en-US" sz="2800" b="1" dirty="0">
                 <a:solidFill>
-                  <a:schemeClr val="tx2"/>
+                  <a:schemeClr val="tx1"/>
                 </a:solidFill>
               </a:rPr>
               <a:t>ご確認事項と次のステップ</a:t>
@@ -3225,7 +3225,7 @@
             <a:r>
               <a:rPr lang="en-US" sz="2800" b="1" dirty="0">
                 <a:solidFill>
-                  <a:schemeClr val="tx2"/>
+                  <a:schemeClr val="tx1"/>
                 </a:solidFill>
               </a:rPr>
               <a:t>経営層の3つの悩みを、IT診断への入口にする</a:t>
@@ -3985,7 +3985,7 @@
             <a:r>
               <a:rPr lang="en-US" sz="2800" b="1" dirty="0">
                 <a:solidFill>
-                  <a:schemeClr val="tx2"/>
+                  <a:schemeClr val="tx1"/>
                 </a:solidFill>
               </a:rPr>
               <a:t>コラムからWP、商談までを一本の導線でつなぐ</a:t>
@@ -5014,7 +5014,7 @@
             <a:r>
               <a:rPr lang="en-US" sz="2800" b="1" dirty="0">
                 <a:solidFill>
-                  <a:schemeClr val="tx2"/>
+                  <a:schemeClr val="tx1"/>
                 </a:solidFill>
               </a:rPr>
               <a:t>悩みとIT診断の8領域を対応づける</a:t>
@@ -5073,7 +5073,7 @@
                   <a:tcPr marL="91440" marR="91440" marT="45720" marB="45720" anchor="ctr">
                     <a:lnL w="12700" cap="flat" cmpd="sng" algn="ctr">
                       <a:solidFill>
-                        <a:srgbClr val="BFD6DA"/>
+                        <a:srgbClr val="D9DDE3"/>
                       </a:solidFill>
                       <a:prstDash val="solid"/>
                       <a:round/>
@@ -5082,7 +5082,7 @@
                     </a:lnL>
                     <a:lnR w="12700" cap="flat" cmpd="sng" algn="ctr">
                       <a:solidFill>
-                        <a:srgbClr val="BFD6DA"/>
+                        <a:srgbClr val="D9DDE3"/>
                       </a:solidFill>
                       <a:prstDash val="solid"/>
                       <a:round/>
@@ -5091,7 +5091,7 @@
                     </a:lnR>
                     <a:lnT w="12700" cap="flat" cmpd="sng" algn="ctr">
                       <a:solidFill>
-                        <a:srgbClr val="BFD6DA"/>
+                        <a:srgbClr val="D9DDE3"/>
                       </a:solidFill>
                       <a:prstDash val="solid"/>
                       <a:round/>
@@ -5100,7 +5100,7 @@
                     </a:lnT>
                     <a:lnB w="12700" cap="flat" cmpd="sng" algn="ctr">
                       <a:solidFill>
-                        <a:srgbClr val="BFD6DA"/>
+                        <a:srgbClr val="D9DDE3"/>
                       </a:solidFill>
                       <a:prstDash val="solid"/>
                       <a:round/>
@@ -5108,7 +5108,7 @@
                       <a:tailEnd type="none" w="med" len="med"/>
                     </a:lnB>
                     <a:solidFill>
-                      <a:srgbClr val="0B4F5C"/>
+                      <a:srgbClr val="1F3A5F"/>
                     </a:solidFill>
                   </a:tcPr>
                 </a:tc>
@@ -5134,7 +5134,7 @@
                   <a:tcPr marL="91440" marR="91440" marT="45720" marB="45720" anchor="ctr">
                     <a:lnL w="12700" cap="flat" cmpd="sng" algn="ctr">
                       <a:solidFill>
-                        <a:srgbClr val="BFD6DA"/>
+                        <a:srgbClr val="D9DDE3"/>
                       </a:solidFill>
                       <a:prstDash val="solid"/>
                       <a:round/>
@@ -5143,7 +5143,7 @@
                     </a:lnL>
                     <a:lnR w="12700" cap="flat" cmpd="sng" algn="ctr">
                       <a:solidFill>
-                        <a:srgbClr val="BFD6DA"/>
+                        <a:srgbClr val="D9DDE3"/>
                       </a:solidFill>
                       <a:prstDash val="solid"/>
                       <a:round/>
@@ -5152,7 +5152,7 @@
                     </a:lnR>
                     <a:lnT w="12700" cap="flat" cmpd="sng" algn="ctr">
                       <a:solidFill>
-                        <a:srgbClr val="BFD6DA"/>
+                        <a:srgbClr val="D9DDE3"/>
                       </a:solidFill>
                       <a:prstDash val="solid"/>
                       <a:round/>
@@ -5161,7 +5161,7 @@
                     </a:lnT>
                     <a:lnB w="12700" cap="flat" cmpd="sng" algn="ctr">
                       <a:solidFill>
-                        <a:srgbClr val="BFD6DA"/>
+                        <a:srgbClr val="D9DDE3"/>
                       </a:solidFill>
                       <a:prstDash val="solid"/>
                       <a:round/>
@@ -5169,7 +5169,7 @@
                       <a:tailEnd type="none" w="med" len="med"/>
                     </a:lnB>
                     <a:solidFill>
-                      <a:srgbClr val="0B4F5C"/>
+                      <a:srgbClr val="1F3A5F"/>
                     </a:solidFill>
                   </a:tcPr>
                 </a:tc>
@@ -5195,7 +5195,7 @@
                   <a:tcPr marL="91440" marR="91440" marT="45720" marB="45720" anchor="ctr">
                     <a:lnL w="12700" cap="flat" cmpd="sng" algn="ctr">
                       <a:solidFill>
-                        <a:srgbClr val="BFD6DA"/>
+                        <a:srgbClr val="D9DDE3"/>
                       </a:solidFill>
                       <a:prstDash val="solid"/>
                       <a:round/>
@@ -5204,7 +5204,7 @@
                     </a:lnL>
                     <a:lnR w="12700" cap="flat" cmpd="sng" algn="ctr">
                       <a:solidFill>
-                        <a:srgbClr val="BFD6DA"/>
+                        <a:srgbClr val="D9DDE3"/>
                       </a:solidFill>
                       <a:prstDash val="solid"/>
                       <a:round/>
@@ -5213,7 +5213,7 @@
                     </a:lnR>
                     <a:lnT w="12700" cap="flat" cmpd="sng" algn="ctr">
                       <a:solidFill>
-                        <a:srgbClr val="BFD6DA"/>
+                        <a:srgbClr val="D9DDE3"/>
                       </a:solidFill>
                       <a:prstDash val="solid"/>
                       <a:round/>
@@ -5222,7 +5222,7 @@
                     </a:lnT>
                     <a:lnB w="12700" cap="flat" cmpd="sng" algn="ctr">
                       <a:solidFill>
-                        <a:srgbClr val="BFD6DA"/>
+                        <a:srgbClr val="D9DDE3"/>
                       </a:solidFill>
                       <a:prstDash val="solid"/>
                       <a:round/>
@@ -5230,7 +5230,7 @@
                       <a:tailEnd type="none" w="med" len="med"/>
                     </a:lnB>
                     <a:solidFill>
-                      <a:srgbClr val="0B4F5C"/>
+                      <a:srgbClr val="1F3A5F"/>
                     </a:solidFill>
                   </a:tcPr>
                 </a:tc>
@@ -5247,7 +5247,7 @@
                       <a:r>
                         <a:rPr lang="en-US" sz="1400" dirty="0">
                           <a:solidFill>
-                            <a:srgbClr val="22313A"/>
+                            <a:srgbClr val="333333"/>
                           </a:solidFill>
                         </a:rPr>
                         <a:t>① IT投資が経営にどう効いているか説明できない</a:t>
@@ -5258,7 +5258,7 @@
                   <a:tcPr marL="91440" marR="91440" marT="45720" marB="45720" anchor="ctr">
                     <a:lnL w="12700" cap="flat" cmpd="sng" algn="ctr">
                       <a:solidFill>
-                        <a:srgbClr val="BFD6DA"/>
+                        <a:srgbClr val="D9DDE3"/>
                       </a:solidFill>
                       <a:prstDash val="solid"/>
                       <a:round/>
@@ -5267,7 +5267,7 @@
                     </a:lnL>
                     <a:lnR w="12700" cap="flat" cmpd="sng" algn="ctr">
                       <a:solidFill>
-                        <a:srgbClr val="BFD6DA"/>
+                        <a:srgbClr val="D9DDE3"/>
                       </a:solidFill>
                       <a:prstDash val="solid"/>
                       <a:round/>
@@ -5276,7 +5276,7 @@
                     </a:lnR>
                     <a:lnT w="12700" cap="flat" cmpd="sng" algn="ctr">
                       <a:solidFill>
-                        <a:srgbClr val="BFD6DA"/>
+                        <a:srgbClr val="D9DDE3"/>
                       </a:solidFill>
                       <a:prstDash val="solid"/>
                       <a:round/>
@@ -5285,7 +5285,7 @@
                     </a:lnT>
                     <a:lnB w="12700" cap="flat" cmpd="sng" algn="ctr">
                       <a:solidFill>
-                        <a:srgbClr val="BFD6DA"/>
+                        <a:srgbClr val="D9DDE3"/>
                       </a:solidFill>
                       <a:prstDash val="solid"/>
                       <a:round/>
@@ -5308,7 +5308,7 @@
                       <a:r>
                         <a:rPr lang="en-US" sz="1400" dirty="0">
                           <a:solidFill>
-                            <a:srgbClr val="22313A"/>
+                            <a:srgbClr val="333333"/>
                           </a:solidFill>
                         </a:rPr>
                         <a:t>IT投資、IT戦略</a:t>
@@ -5319,7 +5319,7 @@
                   <a:tcPr marL="91440" marR="91440" marT="45720" marB="45720" anchor="ctr">
                     <a:lnL w="12700" cap="flat" cmpd="sng" algn="ctr">
                       <a:solidFill>
-                        <a:srgbClr val="BFD6DA"/>
+                        <a:srgbClr val="D9DDE3"/>
                       </a:solidFill>
                       <a:prstDash val="solid"/>
                       <a:round/>
@@ -5328,7 +5328,7 @@
                     </a:lnL>
                     <a:lnR w="12700" cap="flat" cmpd="sng" algn="ctr">
                       <a:solidFill>
-                        <a:srgbClr val="BFD6DA"/>
+                        <a:srgbClr val="D9DDE3"/>
                       </a:solidFill>
                       <a:prstDash val="solid"/>
                       <a:round/>
@@ -5337,7 +5337,7 @@
                     </a:lnR>
                     <a:lnT w="12700" cap="flat" cmpd="sng" algn="ctr">
                       <a:solidFill>
-                        <a:srgbClr val="BFD6DA"/>
+                        <a:srgbClr val="D9DDE3"/>
                       </a:solidFill>
                       <a:prstDash val="solid"/>
                       <a:round/>
@@ -5346,7 +5346,7 @@
                     </a:lnT>
                     <a:lnB w="12700" cap="flat" cmpd="sng" algn="ctr">
                       <a:solidFill>
-                        <a:srgbClr val="BFD6DA"/>
+                        <a:srgbClr val="D9DDE3"/>
                       </a:solidFill>
                       <a:prstDash val="solid"/>
                       <a:round/>
@@ -5369,7 +5369,7 @@
                       <a:r>
                         <a:rPr lang="en-US" sz="1400" b="1" dirty="0">
                           <a:solidFill>
-                            <a:srgbClr val="22313A"/>
+                            <a:srgbClr val="333333"/>
                           </a:solidFill>
                         </a:rPr>
                         <a:t>投資（7問）</a:t>
@@ -5380,7 +5380,7 @@
                   <a:tcPr marL="91440" marR="91440" marT="45720" marB="45720" anchor="ctr">
                     <a:lnL w="12700" cap="flat" cmpd="sng" algn="ctr">
                       <a:solidFill>
-                        <a:srgbClr val="BFD6DA"/>
+                        <a:srgbClr val="D9DDE3"/>
                       </a:solidFill>
                       <a:prstDash val="solid"/>
                       <a:round/>
@@ -5389,7 +5389,7 @@
                     </a:lnL>
                     <a:lnR w="12700" cap="flat" cmpd="sng" algn="ctr">
                       <a:solidFill>
-                        <a:srgbClr val="BFD6DA"/>
+                        <a:srgbClr val="D9DDE3"/>
                       </a:solidFill>
                       <a:prstDash val="solid"/>
                       <a:round/>
@@ -5398,7 +5398,7 @@
                     </a:lnR>
                     <a:lnT w="12700" cap="flat" cmpd="sng" algn="ctr">
                       <a:solidFill>
-                        <a:srgbClr val="BFD6DA"/>
+                        <a:srgbClr val="D9DDE3"/>
                       </a:solidFill>
                       <a:prstDash val="solid"/>
                       <a:round/>
@@ -5407,7 +5407,7 @@
                     </a:lnT>
                     <a:lnB w="12700" cap="flat" cmpd="sng" algn="ctr">
                       <a:solidFill>
-                        <a:srgbClr val="BFD6DA"/>
+                        <a:srgbClr val="D9DDE3"/>
                       </a:solidFill>
                       <a:prstDash val="solid"/>
                       <a:round/>
@@ -5432,7 +5432,7 @@
                       <a:r>
                         <a:rPr lang="en-US" sz="1400" dirty="0">
                           <a:solidFill>
-                            <a:srgbClr val="22313A"/>
+                            <a:srgbClr val="333333"/>
                           </a:solidFill>
                         </a:rPr>
                         <a:t>② IT起因の経営リスクを把握できていない</a:t>
@@ -5443,7 +5443,7 @@
                   <a:tcPr marL="91440" marR="91440" marT="45720" marB="45720" anchor="ctr">
                     <a:lnL w="12700" cap="flat" cmpd="sng" algn="ctr">
                       <a:solidFill>
-                        <a:srgbClr val="BFD6DA"/>
+                        <a:srgbClr val="D9DDE3"/>
                       </a:solidFill>
                       <a:prstDash val="solid"/>
                       <a:round/>
@@ -5452,7 +5452,7 @@
                     </a:lnL>
                     <a:lnR w="12700" cap="flat" cmpd="sng" algn="ctr">
                       <a:solidFill>
-                        <a:srgbClr val="BFD6DA"/>
+                        <a:srgbClr val="D9DDE3"/>
                       </a:solidFill>
                       <a:prstDash val="solid"/>
                       <a:round/>
@@ -5461,7 +5461,7 @@
                     </a:lnR>
                     <a:lnT w="12700" cap="flat" cmpd="sng" algn="ctr">
                       <a:solidFill>
-                        <a:srgbClr val="BFD6DA"/>
+                        <a:srgbClr val="D9DDE3"/>
                       </a:solidFill>
                       <a:prstDash val="solid"/>
                       <a:round/>
@@ -5470,7 +5470,7 @@
                     </a:lnT>
                     <a:lnB w="12700" cap="flat" cmpd="sng" algn="ctr">
                       <a:solidFill>
-                        <a:srgbClr val="BFD6DA"/>
+                        <a:srgbClr val="D9DDE3"/>
                       </a:solidFill>
                       <a:prstDash val="solid"/>
                       <a:round/>
@@ -5493,7 +5493,7 @@
                       <a:r>
                         <a:rPr lang="en-US" sz="1400" dirty="0">
                           <a:solidFill>
-                            <a:srgbClr val="22313A"/>
+                            <a:srgbClr val="333333"/>
                           </a:solidFill>
                         </a:rPr>
                         <a:t>ITリスク（セキュリティ・IT-BCP・内部統制）、IT調達（ベンダー依存）、ITオペレーション</a:t>
@@ -5504,7 +5504,7 @@
                   <a:tcPr marL="91440" marR="91440" marT="45720" marB="45720" anchor="ctr">
                     <a:lnL w="12700" cap="flat" cmpd="sng" algn="ctr">
                       <a:solidFill>
-                        <a:srgbClr val="BFD6DA"/>
+                        <a:srgbClr val="D9DDE3"/>
                       </a:solidFill>
                       <a:prstDash val="solid"/>
                       <a:round/>
@@ -5513,7 +5513,7 @@
                     </a:lnL>
                     <a:lnR w="12700" cap="flat" cmpd="sng" algn="ctr">
                       <a:solidFill>
-                        <a:srgbClr val="BFD6DA"/>
+                        <a:srgbClr val="D9DDE3"/>
                       </a:solidFill>
                       <a:prstDash val="solid"/>
                       <a:round/>
@@ -5522,7 +5522,7 @@
                     </a:lnR>
                     <a:lnT w="12700" cap="flat" cmpd="sng" algn="ctr">
                       <a:solidFill>
-                        <a:srgbClr val="BFD6DA"/>
+                        <a:srgbClr val="D9DDE3"/>
                       </a:solidFill>
                       <a:prstDash val="solid"/>
                       <a:round/>
@@ -5531,7 +5531,7 @@
                     </a:lnT>
                     <a:lnB w="12700" cap="flat" cmpd="sng" algn="ctr">
                       <a:solidFill>
-                        <a:srgbClr val="BFD6DA"/>
+                        <a:srgbClr val="D9DDE3"/>
                       </a:solidFill>
                       <a:prstDash val="solid"/>
                       <a:round/>
@@ -5554,7 +5554,7 @@
                       <a:r>
                         <a:rPr lang="en-US" sz="1400" b="1" dirty="0">
                           <a:solidFill>
-                            <a:srgbClr val="22313A"/>
+                            <a:srgbClr val="333333"/>
                           </a:solidFill>
                         </a:rPr>
                         <a:t>リスク（7問）</a:t>
@@ -5565,7 +5565,7 @@
                   <a:tcPr marL="91440" marR="91440" marT="45720" marB="45720" anchor="ctr">
                     <a:lnL w="12700" cap="flat" cmpd="sng" algn="ctr">
                       <a:solidFill>
-                        <a:srgbClr val="BFD6DA"/>
+                        <a:srgbClr val="D9DDE3"/>
                       </a:solidFill>
                       <a:prstDash val="solid"/>
                       <a:round/>
@@ -5574,7 +5574,7 @@
                     </a:lnL>
                     <a:lnR w="12700" cap="flat" cmpd="sng" algn="ctr">
                       <a:solidFill>
-                        <a:srgbClr val="BFD6DA"/>
+                        <a:srgbClr val="D9DDE3"/>
                       </a:solidFill>
                       <a:prstDash val="solid"/>
                       <a:round/>
@@ -5583,7 +5583,7 @@
                     </a:lnR>
                     <a:lnT w="12700" cap="flat" cmpd="sng" algn="ctr">
                       <a:solidFill>
-                        <a:srgbClr val="BFD6DA"/>
+                        <a:srgbClr val="D9DDE3"/>
                       </a:solidFill>
                       <a:prstDash val="solid"/>
                       <a:round/>
@@ -5592,7 +5592,7 @@
                     </a:lnT>
                     <a:lnB w="12700" cap="flat" cmpd="sng" algn="ctr">
                       <a:solidFill>
-                        <a:srgbClr val="BFD6DA"/>
+                        <a:srgbClr val="D9DDE3"/>
                       </a:solidFill>
                       <a:prstDash val="solid"/>
                       <a:round/>
@@ -5617,7 +5617,7 @@
                       <a:r>
                         <a:rPr lang="en-US" sz="1400" dirty="0">
                           <a:solidFill>
-                            <a:srgbClr val="22313A"/>
+                            <a:srgbClr val="333333"/>
                           </a:solidFill>
                         </a:rPr>
                         <a:t>③ DXで他社に後れを取っていないか不安</a:t>
@@ -5628,7 +5628,7 @@
                   <a:tcPr marL="91440" marR="91440" marT="45720" marB="45720" anchor="ctr">
                     <a:lnL w="12700" cap="flat" cmpd="sng" algn="ctr">
                       <a:solidFill>
-                        <a:srgbClr val="BFD6DA"/>
+                        <a:srgbClr val="D9DDE3"/>
                       </a:solidFill>
                       <a:prstDash val="solid"/>
                       <a:round/>
@@ -5637,7 +5637,7 @@
                     </a:lnL>
                     <a:lnR w="12700" cap="flat" cmpd="sng" algn="ctr">
                       <a:solidFill>
-                        <a:srgbClr val="BFD6DA"/>
+                        <a:srgbClr val="D9DDE3"/>
                       </a:solidFill>
                       <a:prstDash val="solid"/>
                       <a:round/>
@@ -5646,7 +5646,7 @@
                     </a:lnR>
                     <a:lnT w="12700" cap="flat" cmpd="sng" algn="ctr">
                       <a:solidFill>
-                        <a:srgbClr val="BFD6DA"/>
+                        <a:srgbClr val="D9DDE3"/>
                       </a:solidFill>
                       <a:prstDash val="solid"/>
                       <a:round/>
@@ -5655,7 +5655,7 @@
                     </a:lnT>
                     <a:lnB w="12700" cap="flat" cmpd="sng" algn="ctr">
                       <a:solidFill>
-                        <a:srgbClr val="BFD6DA"/>
+                        <a:srgbClr val="D9DDE3"/>
                       </a:solidFill>
                       <a:prstDash val="solid"/>
                       <a:round/>
@@ -5678,7 +5678,7 @@
                       <a:r>
                         <a:rPr lang="en-US" sz="1400" dirty="0">
                           <a:solidFill>
-                            <a:srgbClr val="22313A"/>
+                            <a:srgbClr val="333333"/>
                           </a:solidFill>
                         </a:rPr>
                         <a:t>IT戦略、IT組織/IT人材、アプリケーション、ITアーキテクチャ</a:t>
@@ -5689,7 +5689,7 @@
                   <a:tcPr marL="91440" marR="91440" marT="45720" marB="45720" anchor="ctr">
                     <a:lnL w="12700" cap="flat" cmpd="sng" algn="ctr">
                       <a:solidFill>
-                        <a:srgbClr val="BFD6DA"/>
+                        <a:srgbClr val="D9DDE3"/>
                       </a:solidFill>
                       <a:prstDash val="solid"/>
                       <a:round/>
@@ -5698,7 +5698,7 @@
                     </a:lnL>
                     <a:lnR w="12700" cap="flat" cmpd="sng" algn="ctr">
                       <a:solidFill>
-                        <a:srgbClr val="BFD6DA"/>
+                        <a:srgbClr val="D9DDE3"/>
                       </a:solidFill>
                       <a:prstDash val="solid"/>
                       <a:round/>
@@ -5707,7 +5707,7 @@
                     </a:lnR>
                     <a:lnT w="12700" cap="flat" cmpd="sng" algn="ctr">
                       <a:solidFill>
-                        <a:srgbClr val="BFD6DA"/>
+                        <a:srgbClr val="D9DDE3"/>
                       </a:solidFill>
                       <a:prstDash val="solid"/>
                       <a:round/>
@@ -5716,7 +5716,7 @@
                     </a:lnT>
                     <a:lnB w="12700" cap="flat" cmpd="sng" algn="ctr">
                       <a:solidFill>
-                        <a:srgbClr val="BFD6DA"/>
+                        <a:srgbClr val="D9DDE3"/>
                       </a:solidFill>
                       <a:prstDash val="solid"/>
                       <a:round/>
@@ -5739,7 +5739,7 @@
                       <a:r>
                         <a:rPr lang="en-US" sz="1400" b="1" dirty="0">
                           <a:solidFill>
-                            <a:srgbClr val="22313A"/>
+                            <a:srgbClr val="333333"/>
                           </a:solidFill>
                         </a:rPr>
                         <a:t>競争力（7問）</a:t>
@@ -5750,7 +5750,7 @@
                   <a:tcPr marL="91440" marR="91440" marT="45720" marB="45720" anchor="ctr">
                     <a:lnL w="12700" cap="flat" cmpd="sng" algn="ctr">
                       <a:solidFill>
-                        <a:srgbClr val="BFD6DA"/>
+                        <a:srgbClr val="D9DDE3"/>
                       </a:solidFill>
                       <a:prstDash val="solid"/>
                       <a:round/>
@@ -5759,7 +5759,7 @@
                     </a:lnL>
                     <a:lnR w="12700" cap="flat" cmpd="sng" algn="ctr">
                       <a:solidFill>
-                        <a:srgbClr val="BFD6DA"/>
+                        <a:srgbClr val="D9DDE3"/>
                       </a:solidFill>
                       <a:prstDash val="solid"/>
                       <a:round/>
@@ -5768,7 +5768,7 @@
                     </a:lnR>
                     <a:lnT w="12700" cap="flat" cmpd="sng" algn="ctr">
                       <a:solidFill>
-                        <a:srgbClr val="BFD6DA"/>
+                        <a:srgbClr val="D9DDE3"/>
                       </a:solidFill>
                       <a:prstDash val="solid"/>
                       <a:round/>
@@ -5777,7 +5777,7 @@
                     </a:lnT>
                     <a:lnB w="12700" cap="flat" cmpd="sng" algn="ctr">
                       <a:solidFill>
-                        <a:srgbClr val="BFD6DA"/>
+                        <a:srgbClr val="D9DDE3"/>
                       </a:solidFill>
                       <a:prstDash val="solid"/>
                       <a:round/>
@@ -5927,7 +5927,7 @@
             <a:r>
               <a:rPr lang="en-US" sz="2800" b="1" dirty="0">
                 <a:solidFill>
-                  <a:schemeClr val="tx2"/>
+                  <a:schemeClr val="tx1"/>
                 </a:solidFill>
               </a:rPr>
               <a:t>ホワイトペーパー案：10分で分かるIT健康診断</a:t>
@@ -7058,7 +7058,7 @@
             <a:r>
               <a:rPr lang="en-US" sz="2800" b="1" dirty="0">
                 <a:solidFill>
-                  <a:schemeClr val="tx2"/>
+                  <a:schemeClr val="tx1"/>
                 </a:solidFill>
               </a:rPr>
               <a:t>チェックリストはYES/NOで答え、軸別に点数化する</a:t>
@@ -7446,7 +7446,7 @@
             <a:r>
               <a:rPr lang="en-US" sz="2000" b="1" dirty="0">
                 <a:solidFill>
-                  <a:schemeClr val="bg1"/>
+                  <a:schemeClr val="tx1"/>
                 </a:solidFill>
               </a:rPr>
               <a:t>5〜7点</a:t>
@@ -7482,7 +7482,7 @@
             <a:r>
               <a:rPr lang="en-US" sz="1600" b="1" dirty="0">
                 <a:solidFill>
-                  <a:schemeClr val="bg1"/>
+                  <a:schemeClr val="tx1"/>
                 </a:solidFill>
               </a:rPr>
               <a:t>良好</a:t>
@@ -7603,11 +7603,11 @@
             <a:avLst/>
           </a:prstGeom>
           <a:solidFill>
-            <a:schemeClr val="accent4"/>
+            <a:schemeClr val="accent1"/>
           </a:solidFill>
           <a:ln w="12700">
             <a:solidFill>
-              <a:schemeClr val="accent4"/>
+              <a:schemeClr val="accent1"/>
             </a:solidFill>
             <a:prstDash val="solid"/>
           </a:ln>
@@ -7955,7 +7955,7 @@
             <a:r>
               <a:rPr lang="en-US" sz="2800" b="1" dirty="0">
                 <a:solidFill>
-                  <a:schemeClr val="tx2"/>
+                  <a:schemeClr val="tx1"/>
                 </a:solidFill>
               </a:rPr>
               <a:t>設問のイメージ（全21問のうち9問）</a:t>
@@ -8829,7 +8829,7 @@
             <a:r>
               <a:rPr lang="en-US" sz="2800" b="1" dirty="0">
                 <a:solidFill>
-                  <a:schemeClr val="tx2"/>
+                  <a:schemeClr val="tx1"/>
                 </a:solidFill>
               </a:rPr>
               <a:t>流入コラム案：出口は「チェックリストで現在地を確認」</a:t>
@@ -8889,7 +8889,7 @@
                   <a:tcPr marL="91440" marR="91440" marT="45720" marB="45720" anchor="ctr">
                     <a:lnL w="12700" cap="flat" cmpd="sng" algn="ctr">
                       <a:solidFill>
-                        <a:srgbClr val="BFD6DA"/>
+                        <a:srgbClr val="D9DDE3"/>
                       </a:solidFill>
                       <a:prstDash val="solid"/>
                       <a:round/>
@@ -8898,7 +8898,7 @@
                     </a:lnL>
                     <a:lnR w="12700" cap="flat" cmpd="sng" algn="ctr">
                       <a:solidFill>
-                        <a:srgbClr val="BFD6DA"/>
+                        <a:srgbClr val="D9DDE3"/>
                       </a:solidFill>
                       <a:prstDash val="solid"/>
                       <a:round/>
@@ -8907,7 +8907,7 @@
                     </a:lnR>
                     <a:lnT w="12700" cap="flat" cmpd="sng" algn="ctr">
                       <a:solidFill>
-                        <a:srgbClr val="BFD6DA"/>
+                        <a:srgbClr val="D9DDE3"/>
                       </a:solidFill>
                       <a:prstDash val="solid"/>
                       <a:round/>
@@ -8916,7 +8916,7 @@
                     </a:lnT>
                     <a:lnB w="12700" cap="flat" cmpd="sng" algn="ctr">
                       <a:solidFill>
-                        <a:srgbClr val="BFD6DA"/>
+                        <a:srgbClr val="D9DDE3"/>
                       </a:solidFill>
                       <a:prstDash val="solid"/>
                       <a:round/>
@@ -8924,7 +8924,7 @@
                       <a:tailEnd type="none" w="med" len="med"/>
                     </a:lnB>
                     <a:solidFill>
-                      <a:srgbClr val="0B4F5C"/>
+                      <a:srgbClr val="1F3A5F"/>
                     </a:solidFill>
                   </a:tcPr>
                 </a:tc>
@@ -8950,7 +8950,7 @@
                   <a:tcPr marL="91440" marR="91440" marT="45720" marB="45720" anchor="ctr">
                     <a:lnL w="12700" cap="flat" cmpd="sng" algn="ctr">
                       <a:solidFill>
-                        <a:srgbClr val="BFD6DA"/>
+                        <a:srgbClr val="D9DDE3"/>
                       </a:solidFill>
                       <a:prstDash val="solid"/>
                       <a:round/>
@@ -8959,7 +8959,7 @@
                     </a:lnL>
                     <a:lnR w="12700" cap="flat" cmpd="sng" algn="ctr">
                       <a:solidFill>
-                        <a:srgbClr val="BFD6DA"/>
+                        <a:srgbClr val="D9DDE3"/>
                       </a:solidFill>
                       <a:prstDash val="solid"/>
                       <a:round/>
@@ -8968,7 +8968,7 @@
                     </a:lnR>
                     <a:lnT w="12700" cap="flat" cmpd="sng" algn="ctr">
                       <a:solidFill>
-                        <a:srgbClr val="BFD6DA"/>
+                        <a:srgbClr val="D9DDE3"/>
                       </a:solidFill>
                       <a:prstDash val="solid"/>
                       <a:round/>
@@ -8977,7 +8977,7 @@
                     </a:lnT>
                     <a:lnB w="12700" cap="flat" cmpd="sng" algn="ctr">
                       <a:solidFill>
-                        <a:srgbClr val="BFD6DA"/>
+                        <a:srgbClr val="D9DDE3"/>
                       </a:solidFill>
                       <a:prstDash val="solid"/>
                       <a:round/>
@@ -8985,7 +8985,7 @@
                       <a:tailEnd type="none" w="med" len="med"/>
                     </a:lnB>
                     <a:solidFill>
-                      <a:srgbClr val="0B4F5C"/>
+                      <a:srgbClr val="1F3A5F"/>
                     </a:solidFill>
                   </a:tcPr>
                 </a:tc>
@@ -9011,7 +9011,7 @@
                   <a:tcPr marL="91440" marR="91440" marT="45720" marB="45720" anchor="ctr">
                     <a:lnL w="12700" cap="flat" cmpd="sng" algn="ctr">
                       <a:solidFill>
-                        <a:srgbClr val="BFD6DA"/>
+                        <a:srgbClr val="D9DDE3"/>
                       </a:solidFill>
                       <a:prstDash val="solid"/>
                       <a:round/>
@@ -9020,7 +9020,7 @@
                     </a:lnL>
                     <a:lnR w="12700" cap="flat" cmpd="sng" algn="ctr">
                       <a:solidFill>
-                        <a:srgbClr val="BFD6DA"/>
+                        <a:srgbClr val="D9DDE3"/>
                       </a:solidFill>
                       <a:prstDash val="solid"/>
                       <a:round/>
@@ -9029,7 +9029,7 @@
                     </a:lnR>
                     <a:lnT w="12700" cap="flat" cmpd="sng" algn="ctr">
                       <a:solidFill>
-                        <a:srgbClr val="BFD6DA"/>
+                        <a:srgbClr val="D9DDE3"/>
                       </a:solidFill>
                       <a:prstDash val="solid"/>
                       <a:round/>
@@ -9038,7 +9038,7 @@
                     </a:lnT>
                     <a:lnB w="12700" cap="flat" cmpd="sng" algn="ctr">
                       <a:solidFill>
-                        <a:srgbClr val="BFD6DA"/>
+                        <a:srgbClr val="D9DDE3"/>
                       </a:solidFill>
                       <a:prstDash val="solid"/>
                       <a:round/>
@@ -9046,7 +9046,7 @@
                       <a:tailEnd type="none" w="med" len="med"/>
                     </a:lnB>
                     <a:solidFill>
-                      <a:srgbClr val="0B4F5C"/>
+                      <a:srgbClr val="1F3A5F"/>
                     </a:solidFill>
                   </a:tcPr>
                 </a:tc>
@@ -9072,7 +9072,7 @@
                   <a:tcPr marL="91440" marR="91440" marT="45720" marB="45720" anchor="ctr">
                     <a:lnL w="12700" cap="flat" cmpd="sng" algn="ctr">
                       <a:solidFill>
-                        <a:srgbClr val="BFD6DA"/>
+                        <a:srgbClr val="D9DDE3"/>
                       </a:solidFill>
                       <a:prstDash val="solid"/>
                       <a:round/>
@@ -9081,7 +9081,7 @@
                     </a:lnL>
                     <a:lnR w="12700" cap="flat" cmpd="sng" algn="ctr">
                       <a:solidFill>
-                        <a:srgbClr val="BFD6DA"/>
+                        <a:srgbClr val="D9DDE3"/>
                       </a:solidFill>
                       <a:prstDash val="solid"/>
                       <a:round/>
@@ -9090,7 +9090,7 @@
                     </a:lnR>
                     <a:lnT w="12700" cap="flat" cmpd="sng" algn="ctr">
                       <a:solidFill>
-                        <a:srgbClr val="BFD6DA"/>
+                        <a:srgbClr val="D9DDE3"/>
                       </a:solidFill>
                       <a:prstDash val="solid"/>
                       <a:round/>
@@ -9099,7 +9099,7 @@
                     </a:lnT>
                     <a:lnB w="12700" cap="flat" cmpd="sng" algn="ctr">
                       <a:solidFill>
-                        <a:srgbClr val="BFD6DA"/>
+                        <a:srgbClr val="D9DDE3"/>
                       </a:solidFill>
                       <a:prstDash val="solid"/>
                       <a:round/>
@@ -9107,7 +9107,7 @@
                       <a:tailEnd type="none" w="med" len="med"/>
                     </a:lnB>
                     <a:solidFill>
-                      <a:srgbClr val="0B4F5C"/>
+                      <a:srgbClr val="1F3A5F"/>
                     </a:solidFill>
                   </a:tcPr>
                 </a:tc>
@@ -9124,7 +9124,7 @@
                       <a:r>
                         <a:rPr lang="en-US" sz="1300" dirty="0">
                           <a:solidFill>
-                            <a:srgbClr val="22313A"/>
+                            <a:srgbClr val="333333"/>
                           </a:solidFill>
                         </a:rPr>
                         <a:t>1</a:t>
@@ -9135,7 +9135,7 @@
                   <a:tcPr marL="91440" marR="91440" marT="45720" marB="45720" anchor="ctr">
                     <a:lnL w="12700" cap="flat" cmpd="sng" algn="ctr">
                       <a:solidFill>
-                        <a:srgbClr val="BFD6DA"/>
+                        <a:srgbClr val="D9DDE3"/>
                       </a:solidFill>
                       <a:prstDash val="solid"/>
                       <a:round/>
@@ -9144,7 +9144,7 @@
                     </a:lnL>
                     <a:lnR w="12700" cap="flat" cmpd="sng" algn="ctr">
                       <a:solidFill>
-                        <a:srgbClr val="BFD6DA"/>
+                        <a:srgbClr val="D9DDE3"/>
                       </a:solidFill>
                       <a:prstDash val="solid"/>
                       <a:round/>
@@ -9153,7 +9153,7 @@
                     </a:lnR>
                     <a:lnT w="12700" cap="flat" cmpd="sng" algn="ctr">
                       <a:solidFill>
-                        <a:srgbClr val="BFD6DA"/>
+                        <a:srgbClr val="D9DDE3"/>
                       </a:solidFill>
                       <a:prstDash val="solid"/>
                       <a:round/>
@@ -9162,7 +9162,7 @@
                     </a:lnT>
                     <a:lnB w="12700" cap="flat" cmpd="sng" algn="ctr">
                       <a:solidFill>
-                        <a:srgbClr val="BFD6DA"/>
+                        <a:srgbClr val="D9DDE3"/>
                       </a:solidFill>
                       <a:prstDash val="solid"/>
                       <a:round/>
@@ -9185,7 +9185,7 @@
                       <a:r>
                         <a:rPr lang="en-US" sz="1300" b="1" dirty="0">
                           <a:solidFill>
-                            <a:srgbClr val="22313A"/>
+                            <a:srgbClr val="333333"/>
                           </a:solidFill>
                         </a:rPr>
                         <a:t>投資</a:t>
@@ -9196,7 +9196,7 @@
                   <a:tcPr marL="91440" marR="91440" marT="45720" marB="45720" anchor="ctr">
                     <a:lnL w="12700" cap="flat" cmpd="sng" algn="ctr">
                       <a:solidFill>
-                        <a:srgbClr val="BFD6DA"/>
+                        <a:srgbClr val="D9DDE3"/>
                       </a:solidFill>
                       <a:prstDash val="solid"/>
                       <a:round/>
@@ -9205,7 +9205,7 @@
                     </a:lnL>
                     <a:lnR w="12700" cap="flat" cmpd="sng" algn="ctr">
                       <a:solidFill>
-                        <a:srgbClr val="BFD6DA"/>
+                        <a:srgbClr val="D9DDE3"/>
                       </a:solidFill>
                       <a:prstDash val="solid"/>
                       <a:round/>
@@ -9214,7 +9214,7 @@
                     </a:lnR>
                     <a:lnT w="12700" cap="flat" cmpd="sng" algn="ctr">
                       <a:solidFill>
-                        <a:srgbClr val="BFD6DA"/>
+                        <a:srgbClr val="D9DDE3"/>
                       </a:solidFill>
                       <a:prstDash val="solid"/>
                       <a:round/>
@@ -9223,7 +9223,7 @@
                     </a:lnT>
                     <a:lnB w="12700" cap="flat" cmpd="sng" algn="ctr">
                       <a:solidFill>
-                        <a:srgbClr val="BFD6DA"/>
+                        <a:srgbClr val="D9DDE3"/>
                       </a:solidFill>
                       <a:prstDash val="solid"/>
                       <a:round/>
@@ -9246,7 +9246,7 @@
                       <a:r>
                         <a:rPr lang="en-US" sz="1300" dirty="0">
                           <a:solidFill>
-                            <a:srgbClr val="22313A"/>
+                            <a:srgbClr val="333333"/>
                           </a:solidFill>
                         </a:rPr>
                         <a:t>IT投資の効果を経営に説明できない本当の理由と、投資対効果の考え方</a:t>
@@ -9257,7 +9257,7 @@
                   <a:tcPr marL="91440" marR="91440" marT="45720" marB="45720" anchor="ctr">
                     <a:lnL w="12700" cap="flat" cmpd="sng" algn="ctr">
                       <a:solidFill>
-                        <a:srgbClr val="BFD6DA"/>
+                        <a:srgbClr val="D9DDE3"/>
                       </a:solidFill>
                       <a:prstDash val="solid"/>
                       <a:round/>
@@ -9266,7 +9266,7 @@
                     </a:lnL>
                     <a:lnR w="12700" cap="flat" cmpd="sng" algn="ctr">
                       <a:solidFill>
-                        <a:srgbClr val="BFD6DA"/>
+                        <a:srgbClr val="D9DDE3"/>
                       </a:solidFill>
                       <a:prstDash val="solid"/>
                       <a:round/>
@@ -9275,7 +9275,7 @@
                     </a:lnR>
                     <a:lnT w="12700" cap="flat" cmpd="sng" algn="ctr">
                       <a:solidFill>
-                        <a:srgbClr val="BFD6DA"/>
+                        <a:srgbClr val="D9DDE3"/>
                       </a:solidFill>
                       <a:prstDash val="solid"/>
                       <a:round/>
@@ -9284,7 +9284,7 @@
                     </a:lnT>
                     <a:lnB w="12700" cap="flat" cmpd="sng" algn="ctr">
                       <a:solidFill>
-                        <a:srgbClr val="BFD6DA"/>
+                        <a:srgbClr val="D9DDE3"/>
                       </a:solidFill>
                       <a:prstDash val="solid"/>
                       <a:round/>
@@ -9307,7 +9307,7 @@
                       <a:r>
                         <a:rPr lang="en-US" sz="1300" dirty="0">
                           <a:solidFill>
-                            <a:srgbClr val="22313A"/>
+                            <a:srgbClr val="333333"/>
                           </a:solidFill>
                         </a:rPr>
                         <a:t>IT投資 効果測定、IT投資 ROI</a:t>
@@ -9318,7 +9318,7 @@
                   <a:tcPr marL="91440" marR="91440" marT="45720" marB="45720" anchor="ctr">
                     <a:lnL w="12700" cap="flat" cmpd="sng" algn="ctr">
                       <a:solidFill>
-                        <a:srgbClr val="BFD6DA"/>
+                        <a:srgbClr val="D9DDE3"/>
                       </a:solidFill>
                       <a:prstDash val="solid"/>
                       <a:round/>
@@ -9327,7 +9327,7 @@
                     </a:lnL>
                     <a:lnR w="12700" cap="flat" cmpd="sng" algn="ctr">
                       <a:solidFill>
-                        <a:srgbClr val="BFD6DA"/>
+                        <a:srgbClr val="D9DDE3"/>
                       </a:solidFill>
                       <a:prstDash val="solid"/>
                       <a:round/>
@@ -9336,7 +9336,7 @@
                     </a:lnR>
                     <a:lnT w="12700" cap="flat" cmpd="sng" algn="ctr">
                       <a:solidFill>
-                        <a:srgbClr val="BFD6DA"/>
+                        <a:srgbClr val="D9DDE3"/>
                       </a:solidFill>
                       <a:prstDash val="solid"/>
                       <a:round/>
@@ -9345,7 +9345,7 @@
                     </a:lnT>
                     <a:lnB w="12700" cap="flat" cmpd="sng" algn="ctr">
                       <a:solidFill>
-                        <a:srgbClr val="BFD6DA"/>
+                        <a:srgbClr val="D9DDE3"/>
                       </a:solidFill>
                       <a:prstDash val="solid"/>
                       <a:round/>
@@ -9370,7 +9370,7 @@
                       <a:r>
                         <a:rPr lang="en-US" sz="1300" dirty="0">
                           <a:solidFill>
-                            <a:srgbClr val="22313A"/>
+                            <a:srgbClr val="333333"/>
                           </a:solidFill>
                         </a:rPr>
                         <a:t>2</a:t>
@@ -9381,7 +9381,7 @@
                   <a:tcPr marL="91440" marR="91440" marT="45720" marB="45720" anchor="ctr">
                     <a:lnL w="12700" cap="flat" cmpd="sng" algn="ctr">
                       <a:solidFill>
-                        <a:srgbClr val="BFD6DA"/>
+                        <a:srgbClr val="D9DDE3"/>
                       </a:solidFill>
                       <a:prstDash val="solid"/>
                       <a:round/>
@@ -9390,7 +9390,7 @@
                     </a:lnL>
                     <a:lnR w="12700" cap="flat" cmpd="sng" algn="ctr">
                       <a:solidFill>
-                        <a:srgbClr val="BFD6DA"/>
+                        <a:srgbClr val="D9DDE3"/>
                       </a:solidFill>
                       <a:prstDash val="solid"/>
                       <a:round/>
@@ -9399,7 +9399,7 @@
                     </a:lnR>
                     <a:lnT w="12700" cap="flat" cmpd="sng" algn="ctr">
                       <a:solidFill>
-                        <a:srgbClr val="BFD6DA"/>
+                        <a:srgbClr val="D9DDE3"/>
                       </a:solidFill>
                       <a:prstDash val="solid"/>
                       <a:round/>
@@ -9408,7 +9408,7 @@
                     </a:lnT>
                     <a:lnB w="12700" cap="flat" cmpd="sng" algn="ctr">
                       <a:solidFill>
-                        <a:srgbClr val="BFD6DA"/>
+                        <a:srgbClr val="D9DDE3"/>
                       </a:solidFill>
                       <a:prstDash val="solid"/>
                       <a:round/>
@@ -9431,7 +9431,7 @@
                       <a:r>
                         <a:rPr lang="en-US" sz="1300" b="1" dirty="0">
                           <a:solidFill>
-                            <a:srgbClr val="22313A"/>
+                            <a:srgbClr val="333333"/>
                           </a:solidFill>
                         </a:rPr>
                         <a:t>投資</a:t>
@@ -9442,7 +9442,7 @@
                   <a:tcPr marL="91440" marR="91440" marT="45720" marB="45720" anchor="ctr">
                     <a:lnL w="12700" cap="flat" cmpd="sng" algn="ctr">
                       <a:solidFill>
-                        <a:srgbClr val="BFD6DA"/>
+                        <a:srgbClr val="D9DDE3"/>
                       </a:solidFill>
                       <a:prstDash val="solid"/>
                       <a:round/>
@@ -9451,7 +9451,7 @@
                     </a:lnL>
                     <a:lnR w="12700" cap="flat" cmpd="sng" algn="ctr">
                       <a:solidFill>
-                        <a:srgbClr val="BFD6DA"/>
+                        <a:srgbClr val="D9DDE3"/>
                       </a:solidFill>
                       <a:prstDash val="solid"/>
                       <a:round/>
@@ -9460,7 +9460,7 @@
                     </a:lnR>
                     <a:lnT w="12700" cap="flat" cmpd="sng" algn="ctr">
                       <a:solidFill>
-                        <a:srgbClr val="BFD6DA"/>
+                        <a:srgbClr val="D9DDE3"/>
                       </a:solidFill>
                       <a:prstDash val="solid"/>
                       <a:round/>
@@ -9469,7 +9469,7 @@
                     </a:lnT>
                     <a:lnB w="12700" cap="flat" cmpd="sng" algn="ctr">
                       <a:solidFill>
-                        <a:srgbClr val="BFD6DA"/>
+                        <a:srgbClr val="D9DDE3"/>
                       </a:solidFill>
                       <a:prstDash val="solid"/>
                       <a:round/>
@@ -9492,7 +9492,7 @@
                       <a:r>
                         <a:rPr lang="en-US" sz="1300" dirty="0">
                           <a:solidFill>
-                            <a:srgbClr val="22313A"/>
+                            <a:srgbClr val="333333"/>
                           </a:solidFill>
                         </a:rPr>
                         <a:t>取締役会・経営会議で承認されるIT投資計画の作り方</a:t>
@@ -9503,7 +9503,7 @@
                   <a:tcPr marL="91440" marR="91440" marT="45720" marB="45720" anchor="ctr">
                     <a:lnL w="12700" cap="flat" cmpd="sng" algn="ctr">
                       <a:solidFill>
-                        <a:srgbClr val="BFD6DA"/>
+                        <a:srgbClr val="D9DDE3"/>
                       </a:solidFill>
                       <a:prstDash val="solid"/>
                       <a:round/>
@@ -9512,7 +9512,7 @@
                     </a:lnL>
                     <a:lnR w="12700" cap="flat" cmpd="sng" algn="ctr">
                       <a:solidFill>
-                        <a:srgbClr val="BFD6DA"/>
+                        <a:srgbClr val="D9DDE3"/>
                       </a:solidFill>
                       <a:prstDash val="solid"/>
                       <a:round/>
@@ -9521,7 +9521,7 @@
                     </a:lnR>
                     <a:lnT w="12700" cap="flat" cmpd="sng" algn="ctr">
                       <a:solidFill>
-                        <a:srgbClr val="BFD6DA"/>
+                        <a:srgbClr val="D9DDE3"/>
                       </a:solidFill>
                       <a:prstDash val="solid"/>
                       <a:round/>
@@ -9530,7 +9530,7 @@
                     </a:lnT>
                     <a:lnB w="12700" cap="flat" cmpd="sng" algn="ctr">
                       <a:solidFill>
-                        <a:srgbClr val="BFD6DA"/>
+                        <a:srgbClr val="D9DDE3"/>
                       </a:solidFill>
                       <a:prstDash val="solid"/>
                       <a:round/>
@@ -9553,7 +9553,7 @@
                       <a:r>
                         <a:rPr lang="en-US" sz="1300" dirty="0">
                           <a:solidFill>
-                            <a:srgbClr val="22313A"/>
+                            <a:srgbClr val="333333"/>
                           </a:solidFill>
                         </a:rPr>
                         <a:t>IT投資計画、IT中期計画</a:t>
@@ -9564,7 +9564,7 @@
                   <a:tcPr marL="91440" marR="91440" marT="45720" marB="45720" anchor="ctr">
                     <a:lnL w="12700" cap="flat" cmpd="sng" algn="ctr">
                       <a:solidFill>
-                        <a:srgbClr val="BFD6DA"/>
+                        <a:srgbClr val="D9DDE3"/>
                       </a:solidFill>
                       <a:prstDash val="solid"/>
                       <a:round/>
@@ -9573,7 +9573,7 @@
                     </a:lnL>
                     <a:lnR w="12700" cap="flat" cmpd="sng" algn="ctr">
                       <a:solidFill>
-                        <a:srgbClr val="BFD6DA"/>
+                        <a:srgbClr val="D9DDE3"/>
                       </a:solidFill>
                       <a:prstDash val="solid"/>
                       <a:round/>
@@ -9582,7 +9582,7 @@
                     </a:lnR>
                     <a:lnT w="12700" cap="flat" cmpd="sng" algn="ctr">
                       <a:solidFill>
-                        <a:srgbClr val="BFD6DA"/>
+                        <a:srgbClr val="D9DDE3"/>
                       </a:solidFill>
                       <a:prstDash val="solid"/>
                       <a:round/>
@@ -9591,7 +9591,7 @@
                     </a:lnT>
                     <a:lnB w="12700" cap="flat" cmpd="sng" algn="ctr">
                       <a:solidFill>
-                        <a:srgbClr val="BFD6DA"/>
+                        <a:srgbClr val="D9DDE3"/>
                       </a:solidFill>
                       <a:prstDash val="solid"/>
                       <a:round/>
@@ -9616,7 +9616,7 @@
                       <a:r>
                         <a:rPr lang="en-US" sz="1300" dirty="0">
                           <a:solidFill>
-                            <a:srgbClr val="22313A"/>
+                            <a:srgbClr val="333333"/>
                           </a:solidFill>
                         </a:rPr>
                         <a:t>3</a:t>
@@ -9627,7 +9627,7 @@
                   <a:tcPr marL="91440" marR="91440" marT="45720" marB="45720" anchor="ctr">
                     <a:lnL w="12700" cap="flat" cmpd="sng" algn="ctr">
                       <a:solidFill>
-                        <a:srgbClr val="BFD6DA"/>
+                        <a:srgbClr val="D9DDE3"/>
                       </a:solidFill>
                       <a:prstDash val="solid"/>
                       <a:round/>
@@ -9636,7 +9636,7 @@
                     </a:lnL>
                     <a:lnR w="12700" cap="flat" cmpd="sng" algn="ctr">
                       <a:solidFill>
-                        <a:srgbClr val="BFD6DA"/>
+                        <a:srgbClr val="D9DDE3"/>
                       </a:solidFill>
                       <a:prstDash val="solid"/>
                       <a:round/>
@@ -9645,7 +9645,7 @@
                     </a:lnR>
                     <a:lnT w="12700" cap="flat" cmpd="sng" algn="ctr">
                       <a:solidFill>
-                        <a:srgbClr val="BFD6DA"/>
+                        <a:srgbClr val="D9DDE3"/>
                       </a:solidFill>
                       <a:prstDash val="solid"/>
                       <a:round/>
@@ -9654,7 +9654,7 @@
                     </a:lnT>
                     <a:lnB w="12700" cap="flat" cmpd="sng" algn="ctr">
                       <a:solidFill>
-                        <a:srgbClr val="BFD6DA"/>
+                        <a:srgbClr val="D9DDE3"/>
                       </a:solidFill>
                       <a:prstDash val="solid"/>
                       <a:round/>
@@ -9677,7 +9677,7 @@
                       <a:r>
                         <a:rPr lang="en-US" sz="1300" b="1" dirty="0">
                           <a:solidFill>
-                            <a:srgbClr val="22313A"/>
+                            <a:srgbClr val="333333"/>
                           </a:solidFill>
                         </a:rPr>
                         <a:t>リスク</a:t>
@@ -9688,7 +9688,7 @@
                   <a:tcPr marL="91440" marR="91440" marT="45720" marB="45720" anchor="ctr">
                     <a:lnL w="12700" cap="flat" cmpd="sng" algn="ctr">
                       <a:solidFill>
-                        <a:srgbClr val="BFD6DA"/>
+                        <a:srgbClr val="D9DDE3"/>
                       </a:solidFill>
                       <a:prstDash val="solid"/>
                       <a:round/>
@@ -9697,7 +9697,7 @@
                     </a:lnL>
                     <a:lnR w="12700" cap="flat" cmpd="sng" algn="ctr">
                       <a:solidFill>
-                        <a:srgbClr val="BFD6DA"/>
+                        <a:srgbClr val="D9DDE3"/>
                       </a:solidFill>
                       <a:prstDash val="solid"/>
                       <a:round/>
@@ -9706,7 +9706,7 @@
                     </a:lnR>
                     <a:lnT w="12700" cap="flat" cmpd="sng" algn="ctr">
                       <a:solidFill>
-                        <a:srgbClr val="BFD6DA"/>
+                        <a:srgbClr val="D9DDE3"/>
                       </a:solidFill>
                       <a:prstDash val="solid"/>
                       <a:round/>
@@ -9715,7 +9715,7 @@
                     </a:lnT>
                     <a:lnB w="12700" cap="flat" cmpd="sng" algn="ctr">
                       <a:solidFill>
-                        <a:srgbClr val="BFD6DA"/>
+                        <a:srgbClr val="D9DDE3"/>
                       </a:solidFill>
                       <a:prstDash val="solid"/>
                       <a:round/>
@@ -9738,7 +9738,7 @@
                       <a:r>
                         <a:rPr lang="en-US" sz="1300" dirty="0">
                           <a:solidFill>
-                            <a:srgbClr val="22313A"/>
+                            <a:srgbClr val="333333"/>
                           </a:solidFill>
                         </a:rPr>
                         <a:t>経営者が押さえるべきITリスク5分類</a:t>
@@ -9749,7 +9749,7 @@
                   <a:tcPr marL="91440" marR="91440" marT="45720" marB="45720" anchor="ctr">
                     <a:lnL w="12700" cap="flat" cmpd="sng" algn="ctr">
                       <a:solidFill>
-                        <a:srgbClr val="BFD6DA"/>
+                        <a:srgbClr val="D9DDE3"/>
                       </a:solidFill>
                       <a:prstDash val="solid"/>
                       <a:round/>
@@ -9758,7 +9758,7 @@
                     </a:lnL>
                     <a:lnR w="12700" cap="flat" cmpd="sng" algn="ctr">
                       <a:solidFill>
-                        <a:srgbClr val="BFD6DA"/>
+                        <a:srgbClr val="D9DDE3"/>
                       </a:solidFill>
                       <a:prstDash val="solid"/>
                       <a:round/>
@@ -9767,7 +9767,7 @@
                     </a:lnR>
                     <a:lnT w="12700" cap="flat" cmpd="sng" algn="ctr">
                       <a:solidFill>
-                        <a:srgbClr val="BFD6DA"/>
+                        <a:srgbClr val="D9DDE3"/>
                       </a:solidFill>
                       <a:prstDash val="solid"/>
                       <a:round/>
@@ -9776,7 +9776,7 @@
                     </a:lnT>
                     <a:lnB w="12700" cap="flat" cmpd="sng" algn="ctr">
                       <a:solidFill>
-                        <a:srgbClr val="BFD6DA"/>
+                        <a:srgbClr val="D9DDE3"/>
                       </a:solidFill>
                       <a:prstDash val="solid"/>
                       <a:round/>
@@ -9799,7 +9799,7 @@
                       <a:r>
                         <a:rPr lang="en-US" sz="1300" dirty="0">
                           <a:solidFill>
-                            <a:srgbClr val="22313A"/>
+                            <a:srgbClr val="333333"/>
                           </a:solidFill>
                         </a:rPr>
                         <a:t>ITリスク 経営、IT統制</a:t>
@@ -9810,7 +9810,7 @@
                   <a:tcPr marL="91440" marR="91440" marT="45720" marB="45720" anchor="ctr">
                     <a:lnL w="12700" cap="flat" cmpd="sng" algn="ctr">
                       <a:solidFill>
-                        <a:srgbClr val="BFD6DA"/>
+                        <a:srgbClr val="D9DDE3"/>
                       </a:solidFill>
                       <a:prstDash val="solid"/>
                       <a:round/>
@@ -9819,7 +9819,7 @@
                     </a:lnL>
                     <a:lnR w="12700" cap="flat" cmpd="sng" algn="ctr">
                       <a:solidFill>
-                        <a:srgbClr val="BFD6DA"/>
+                        <a:srgbClr val="D9DDE3"/>
                       </a:solidFill>
                       <a:prstDash val="solid"/>
                       <a:round/>
@@ -9828,7 +9828,7 @@
                     </a:lnR>
                     <a:lnT w="12700" cap="flat" cmpd="sng" algn="ctr">
                       <a:solidFill>
-                        <a:srgbClr val="BFD6DA"/>
+                        <a:srgbClr val="D9DDE3"/>
                       </a:solidFill>
                       <a:prstDash val="solid"/>
                       <a:round/>
@@ -9837,7 +9837,7 @@
                     </a:lnT>
                     <a:lnB w="12700" cap="flat" cmpd="sng" algn="ctr">
                       <a:solidFill>
-                        <a:srgbClr val="BFD6DA"/>
+                        <a:srgbClr val="D9DDE3"/>
                       </a:solidFill>
                       <a:prstDash val="solid"/>
                       <a:round/>
@@ -9862,7 +9862,7 @@
                       <a:r>
                         <a:rPr lang="en-US" sz="1300" dirty="0">
                           <a:solidFill>
-                            <a:srgbClr val="22313A"/>
+                            <a:srgbClr val="333333"/>
                           </a:solidFill>
                         </a:rPr>
                         <a:t>4</a:t>
@@ -9873,7 +9873,7 @@
                   <a:tcPr marL="91440" marR="91440" marT="45720" marB="45720" anchor="ctr">
                     <a:lnL w="12700" cap="flat" cmpd="sng" algn="ctr">
                       <a:solidFill>
-                        <a:srgbClr val="BFD6DA"/>
+                        <a:srgbClr val="D9DDE3"/>
                       </a:solidFill>
                       <a:prstDash val="solid"/>
                       <a:round/>
@@ -9882,7 +9882,7 @@
                     </a:lnL>
                     <a:lnR w="12700" cap="flat" cmpd="sng" algn="ctr">
                       <a:solidFill>
-                        <a:srgbClr val="BFD6DA"/>
+                        <a:srgbClr val="D9DDE3"/>
                       </a:solidFill>
                       <a:prstDash val="solid"/>
                       <a:round/>
@@ -9891,7 +9891,7 @@
                     </a:lnR>
                     <a:lnT w="12700" cap="flat" cmpd="sng" algn="ctr">
                       <a:solidFill>
-                        <a:srgbClr val="BFD6DA"/>
+                        <a:srgbClr val="D9DDE3"/>
                       </a:solidFill>
                       <a:prstDash val="solid"/>
                       <a:round/>
@@ -9900,7 +9900,7 @@
                     </a:lnT>
                     <a:lnB w="12700" cap="flat" cmpd="sng" algn="ctr">
                       <a:solidFill>
-                        <a:srgbClr val="BFD6DA"/>
+                        <a:srgbClr val="D9DDE3"/>
                       </a:solidFill>
                       <a:prstDash val="solid"/>
                       <a:round/>
@@ -9923,7 +9923,7 @@
                       <a:r>
                         <a:rPr lang="en-US" sz="1300" b="1" dirty="0">
                           <a:solidFill>
-                            <a:srgbClr val="22313A"/>
+                            <a:srgbClr val="333333"/>
                           </a:solidFill>
                         </a:rPr>
                         <a:t>リスク</a:t>
@@ -9934,7 +9934,7 @@
                   <a:tcPr marL="91440" marR="91440" marT="45720" marB="45720" anchor="ctr">
                     <a:lnL w="12700" cap="flat" cmpd="sng" algn="ctr">
                       <a:solidFill>
-                        <a:srgbClr val="BFD6DA"/>
+                        <a:srgbClr val="D9DDE3"/>
                       </a:solidFill>
                       <a:prstDash val="solid"/>
                       <a:round/>
@@ -9943,7 +9943,7 @@
                     </a:lnL>
                     <a:lnR w="12700" cap="flat" cmpd="sng" algn="ctr">
                       <a:solidFill>
-                        <a:srgbClr val="BFD6DA"/>
+                        <a:srgbClr val="D9DDE3"/>
                       </a:solidFill>
                       <a:prstDash val="solid"/>
                       <a:round/>
@@ -9952,7 +9952,7 @@
                     </a:lnR>
                     <a:lnT w="12700" cap="flat" cmpd="sng" algn="ctr">
                       <a:solidFill>
-                        <a:srgbClr val="BFD6DA"/>
+                        <a:srgbClr val="D9DDE3"/>
                       </a:solidFill>
                       <a:prstDash val="solid"/>
                       <a:round/>
@@ -9961,7 +9961,7 @@
                     </a:lnT>
                     <a:lnB w="12700" cap="flat" cmpd="sng" algn="ctr">
                       <a:solidFill>
-                        <a:srgbClr val="BFD6DA"/>
+                        <a:srgbClr val="D9DDE3"/>
                       </a:solidFill>
                       <a:prstDash val="solid"/>
                       <a:round/>
@@ -9984,7 +9984,7 @@
                       <a:r>
                         <a:rPr lang="en-US" sz="1300" dirty="0">
                           <a:solidFill>
-                            <a:srgbClr val="22313A"/>
+                            <a:srgbClr val="333333"/>
                           </a:solidFill>
                         </a:rPr>
                         <a:t>IT-BCPとは？「止まったらどうなるか」を経営が答えられるか</a:t>
@@ -9995,7 +9995,7 @@
                   <a:tcPr marL="91440" marR="91440" marT="45720" marB="45720" anchor="ctr">
                     <a:lnL w="12700" cap="flat" cmpd="sng" algn="ctr">
                       <a:solidFill>
-                        <a:srgbClr val="BFD6DA"/>
+                        <a:srgbClr val="D9DDE3"/>
                       </a:solidFill>
                       <a:prstDash val="solid"/>
                       <a:round/>
@@ -10004,7 +10004,7 @@
                     </a:lnL>
                     <a:lnR w="12700" cap="flat" cmpd="sng" algn="ctr">
                       <a:solidFill>
-                        <a:srgbClr val="BFD6DA"/>
+                        <a:srgbClr val="D9DDE3"/>
                       </a:solidFill>
                       <a:prstDash val="solid"/>
                       <a:round/>
@@ -10013,7 +10013,7 @@
                     </a:lnR>
                     <a:lnT w="12700" cap="flat" cmpd="sng" algn="ctr">
                       <a:solidFill>
-                        <a:srgbClr val="BFD6DA"/>
+                        <a:srgbClr val="D9DDE3"/>
                       </a:solidFill>
                       <a:prstDash val="solid"/>
                       <a:round/>
@@ -10022,7 +10022,7 @@
                     </a:lnT>
                     <a:lnB w="12700" cap="flat" cmpd="sng" algn="ctr">
                       <a:solidFill>
-                        <a:srgbClr val="BFD6DA"/>
+                        <a:srgbClr val="D9DDE3"/>
                       </a:solidFill>
                       <a:prstDash val="solid"/>
                       <a:round/>
@@ -10045,7 +10045,7 @@
                       <a:r>
                         <a:rPr lang="en-US" sz="1300" dirty="0">
                           <a:solidFill>
-                            <a:srgbClr val="22313A"/>
+                            <a:srgbClr val="333333"/>
                           </a:solidFill>
                         </a:rPr>
                         <a:t>IT-BCP とは、システム停止 事業影響</a:t>
@@ -10056,7 +10056,7 @@
                   <a:tcPr marL="91440" marR="91440" marT="45720" marB="45720" anchor="ctr">
                     <a:lnL w="12700" cap="flat" cmpd="sng" algn="ctr">
                       <a:solidFill>
-                        <a:srgbClr val="BFD6DA"/>
+                        <a:srgbClr val="D9DDE3"/>
                       </a:solidFill>
                       <a:prstDash val="solid"/>
                       <a:round/>
@@ -10065,7 +10065,7 @@
                     </a:lnL>
                     <a:lnR w="12700" cap="flat" cmpd="sng" algn="ctr">
                       <a:solidFill>
-                        <a:srgbClr val="BFD6DA"/>
+                        <a:srgbClr val="D9DDE3"/>
                       </a:solidFill>
                       <a:prstDash val="solid"/>
                       <a:round/>
@@ -10074,7 +10074,7 @@
                     </a:lnR>
                     <a:lnT w="12700" cap="flat" cmpd="sng" algn="ctr">
                       <a:solidFill>
-                        <a:srgbClr val="BFD6DA"/>
+                        <a:srgbClr val="D9DDE3"/>
                       </a:solidFill>
                       <a:prstDash val="solid"/>
                       <a:round/>
@@ -10083,7 +10083,7 @@
                     </a:lnT>
                     <a:lnB w="12700" cap="flat" cmpd="sng" algn="ctr">
                       <a:solidFill>
-                        <a:srgbClr val="BFD6DA"/>
+                        <a:srgbClr val="D9DDE3"/>
                       </a:solidFill>
                       <a:prstDash val="solid"/>
                       <a:round/>
@@ -10108,7 +10108,7 @@
                       <a:r>
                         <a:rPr lang="en-US" sz="1300" dirty="0">
                           <a:solidFill>
-                            <a:srgbClr val="22313A"/>
+                            <a:srgbClr val="333333"/>
                           </a:solidFill>
                         </a:rPr>
                         <a:t>5</a:t>
@@ -10119,7 +10119,7 @@
                   <a:tcPr marL="91440" marR="91440" marT="45720" marB="45720" anchor="ctr">
                     <a:lnL w="12700" cap="flat" cmpd="sng" algn="ctr">
                       <a:solidFill>
-                        <a:srgbClr val="BFD6DA"/>
+                        <a:srgbClr val="D9DDE3"/>
                       </a:solidFill>
                       <a:prstDash val="solid"/>
                       <a:round/>
@@ -10128,7 +10128,7 @@
                     </a:lnL>
                     <a:lnR w="12700" cap="flat" cmpd="sng" algn="ctr">
                       <a:solidFill>
-                        <a:srgbClr val="BFD6DA"/>
+                        <a:srgbClr val="D9DDE3"/>
                       </a:solidFill>
                       <a:prstDash val="solid"/>
                       <a:round/>
@@ -10137,7 +10137,7 @@
                     </a:lnR>
                     <a:lnT w="12700" cap="flat" cmpd="sng" algn="ctr">
                       <a:solidFill>
-                        <a:srgbClr val="BFD6DA"/>
+                        <a:srgbClr val="D9DDE3"/>
                       </a:solidFill>
                       <a:prstDash val="solid"/>
                       <a:round/>
@@ -10146,7 +10146,7 @@
                     </a:lnT>
                     <a:lnB w="12700" cap="flat" cmpd="sng" algn="ctr">
                       <a:solidFill>
-                        <a:srgbClr val="BFD6DA"/>
+                        <a:srgbClr val="D9DDE3"/>
                       </a:solidFill>
                       <a:prstDash val="solid"/>
                       <a:round/>
@@ -10169,7 +10169,7 @@
                       <a:r>
                         <a:rPr lang="en-US" sz="1300" b="1" dirty="0">
                           <a:solidFill>
-                            <a:srgbClr val="22313A"/>
+                            <a:srgbClr val="333333"/>
                           </a:solidFill>
                         </a:rPr>
                         <a:t>競争力</a:t>
@@ -10180,7 +10180,7 @@
                   <a:tcPr marL="91440" marR="91440" marT="45720" marB="45720" anchor="ctr">
                     <a:lnL w="12700" cap="flat" cmpd="sng" algn="ctr">
                       <a:solidFill>
-                        <a:srgbClr val="BFD6DA"/>
+                        <a:srgbClr val="D9DDE3"/>
                       </a:solidFill>
                       <a:prstDash val="solid"/>
                       <a:round/>
@@ -10189,7 +10189,7 @@
                     </a:lnL>
                     <a:lnR w="12700" cap="flat" cmpd="sng" algn="ctr">
                       <a:solidFill>
-                        <a:srgbClr val="BFD6DA"/>
+                        <a:srgbClr val="D9DDE3"/>
                       </a:solidFill>
                       <a:prstDash val="solid"/>
                       <a:round/>
@@ -10198,7 +10198,7 @@
                     </a:lnR>
                     <a:lnT w="12700" cap="flat" cmpd="sng" algn="ctr">
                       <a:solidFill>
-                        <a:srgbClr val="BFD6DA"/>
+                        <a:srgbClr val="D9DDE3"/>
                       </a:solidFill>
                       <a:prstDash val="solid"/>
                       <a:round/>
@@ -10207,7 +10207,7 @@
                     </a:lnT>
                     <a:lnB w="12700" cap="flat" cmpd="sng" algn="ctr">
                       <a:solidFill>
-                        <a:srgbClr val="BFD6DA"/>
+                        <a:srgbClr val="D9DDE3"/>
                       </a:solidFill>
                       <a:prstDash val="solid"/>
                       <a:round/>
@@ -10230,7 +10230,7 @@
                       <a:r>
                         <a:rPr lang="en-US" sz="1300" dirty="0">
                           <a:solidFill>
-                            <a:srgbClr val="22313A"/>
+                            <a:srgbClr val="333333"/>
                           </a:solidFill>
                         </a:rPr>
                         <a:t>DXで他社に後れを取っているか？経営層向け自己チェックの観点</a:t>
@@ -10241,7 +10241,7 @@
                   <a:tcPr marL="91440" marR="91440" marT="45720" marB="45720" anchor="ctr">
                     <a:lnL w="12700" cap="flat" cmpd="sng" algn="ctr">
                       <a:solidFill>
-                        <a:srgbClr val="BFD6DA"/>
+                        <a:srgbClr val="D9DDE3"/>
                       </a:solidFill>
                       <a:prstDash val="solid"/>
                       <a:round/>
@@ -10250,7 +10250,7 @@
                     </a:lnL>
                     <a:lnR w="12700" cap="flat" cmpd="sng" algn="ctr">
                       <a:solidFill>
-                        <a:srgbClr val="BFD6DA"/>
+                        <a:srgbClr val="D9DDE3"/>
                       </a:solidFill>
                       <a:prstDash val="solid"/>
                       <a:round/>
@@ -10259,7 +10259,7 @@
                     </a:lnR>
                     <a:lnT w="12700" cap="flat" cmpd="sng" algn="ctr">
                       <a:solidFill>
-                        <a:srgbClr val="BFD6DA"/>
+                        <a:srgbClr val="D9DDE3"/>
                       </a:solidFill>
                       <a:prstDash val="solid"/>
                       <a:round/>
@@ -10268,7 +10268,7 @@
                     </a:lnT>
                     <a:lnB w="12700" cap="flat" cmpd="sng" algn="ctr">
                       <a:solidFill>
-                        <a:srgbClr val="BFD6DA"/>
+                        <a:srgbClr val="D9DDE3"/>
                       </a:solidFill>
                       <a:prstDash val="solid"/>
                       <a:round/>
@@ -10291,7 +10291,7 @@
                       <a:r>
                         <a:rPr lang="en-US" sz="1300" dirty="0">
                           <a:solidFill>
-                            <a:srgbClr val="22313A"/>
+                            <a:srgbClr val="333333"/>
                           </a:solidFill>
                         </a:rPr>
                         <a:t>DX 遅れ、DX 自社 評価</a:t>
@@ -10302,7 +10302,7 @@
                   <a:tcPr marL="91440" marR="91440" marT="45720" marB="45720" anchor="ctr">
                     <a:lnL w="12700" cap="flat" cmpd="sng" algn="ctr">
                       <a:solidFill>
-                        <a:srgbClr val="BFD6DA"/>
+                        <a:srgbClr val="D9DDE3"/>
                       </a:solidFill>
                       <a:prstDash val="solid"/>
                       <a:round/>
@@ -10311,7 +10311,7 @@
                     </a:lnL>
                     <a:lnR w="12700" cap="flat" cmpd="sng" algn="ctr">
                       <a:solidFill>
-                        <a:srgbClr val="BFD6DA"/>
+                        <a:srgbClr val="D9DDE3"/>
                       </a:solidFill>
                       <a:prstDash val="solid"/>
                       <a:round/>
@@ -10320,7 +10320,7 @@
                     </a:lnR>
                     <a:lnT w="12700" cap="flat" cmpd="sng" algn="ctr">
                       <a:solidFill>
-                        <a:srgbClr val="BFD6DA"/>
+                        <a:srgbClr val="D9DDE3"/>
                       </a:solidFill>
                       <a:prstDash val="solid"/>
                       <a:round/>
@@ -10329,7 +10329,7 @@
                     </a:lnT>
                     <a:lnB w="12700" cap="flat" cmpd="sng" algn="ctr">
                       <a:solidFill>
-                        <a:srgbClr val="BFD6DA"/>
+                        <a:srgbClr val="D9DDE3"/>
                       </a:solidFill>
                       <a:prstDash val="solid"/>
                       <a:round/>
@@ -10354,7 +10354,7 @@
                       <a:r>
                         <a:rPr lang="en-US" sz="1300" dirty="0">
                           <a:solidFill>
-                            <a:srgbClr val="22313A"/>
+                            <a:srgbClr val="333333"/>
                           </a:solidFill>
                         </a:rPr>
                         <a:t>6</a:t>
@@ -10365,7 +10365,7 @@
                   <a:tcPr marL="91440" marR="91440" marT="45720" marB="45720" anchor="ctr">
                     <a:lnL w="12700" cap="flat" cmpd="sng" algn="ctr">
                       <a:solidFill>
-                        <a:srgbClr val="BFD6DA"/>
+                        <a:srgbClr val="D9DDE3"/>
                       </a:solidFill>
                       <a:prstDash val="solid"/>
                       <a:round/>
@@ -10374,7 +10374,7 @@
                     </a:lnL>
                     <a:lnR w="12700" cap="flat" cmpd="sng" algn="ctr">
                       <a:solidFill>
-                        <a:srgbClr val="BFD6DA"/>
+                        <a:srgbClr val="D9DDE3"/>
                       </a:solidFill>
                       <a:prstDash val="solid"/>
                       <a:round/>
@@ -10383,7 +10383,7 @@
                     </a:lnR>
                     <a:lnT w="12700" cap="flat" cmpd="sng" algn="ctr">
                       <a:solidFill>
-                        <a:srgbClr val="BFD6DA"/>
+                        <a:srgbClr val="D9DDE3"/>
                       </a:solidFill>
                       <a:prstDash val="solid"/>
                       <a:round/>
@@ -10392,7 +10392,7 @@
                     </a:lnT>
                     <a:lnB w="12700" cap="flat" cmpd="sng" algn="ctr">
                       <a:solidFill>
-                        <a:srgbClr val="BFD6DA"/>
+                        <a:srgbClr val="D9DDE3"/>
                       </a:solidFill>
                       <a:prstDash val="solid"/>
                       <a:round/>
@@ -10415,7 +10415,7 @@
                       <a:r>
                         <a:rPr lang="en-US" sz="1300" b="1" dirty="0">
                           <a:solidFill>
-                            <a:srgbClr val="22313A"/>
+                            <a:srgbClr val="333333"/>
                           </a:solidFill>
                         </a:rPr>
                         <a:t>競争力</a:t>
@@ -10426,7 +10426,7 @@
                   <a:tcPr marL="91440" marR="91440" marT="45720" marB="45720" anchor="ctr">
                     <a:lnL w="12700" cap="flat" cmpd="sng" algn="ctr">
                       <a:solidFill>
-                        <a:srgbClr val="BFD6DA"/>
+                        <a:srgbClr val="D9DDE3"/>
                       </a:solidFill>
                       <a:prstDash val="solid"/>
                       <a:round/>
@@ -10435,7 +10435,7 @@
                     </a:lnL>
                     <a:lnR w="12700" cap="flat" cmpd="sng" algn="ctr">
                       <a:solidFill>
-                        <a:srgbClr val="BFD6DA"/>
+                        <a:srgbClr val="D9DDE3"/>
                       </a:solidFill>
                       <a:prstDash val="solid"/>
                       <a:round/>
@@ -10444,7 +10444,7 @@
                     </a:lnR>
                     <a:lnT w="12700" cap="flat" cmpd="sng" algn="ctr">
                       <a:solidFill>
-                        <a:srgbClr val="BFD6DA"/>
+                        <a:srgbClr val="D9DDE3"/>
                       </a:solidFill>
                       <a:prstDash val="solid"/>
                       <a:round/>
@@ -10453,7 +10453,7 @@
                     </a:lnT>
                     <a:lnB w="12700" cap="flat" cmpd="sng" algn="ctr">
                       <a:solidFill>
-                        <a:srgbClr val="BFD6DA"/>
+                        <a:srgbClr val="D9DDE3"/>
                       </a:solidFill>
                       <a:prstDash val="solid"/>
                       <a:round/>
@@ -10476,7 +10476,7 @@
                       <a:r>
                         <a:rPr lang="en-US" sz="1300" dirty="0">
                           <a:solidFill>
-                            <a:srgbClr val="22313A"/>
+                            <a:srgbClr val="333333"/>
                           </a:solidFill>
                         </a:rPr>
                         <a:t>IT戦略と経営戦略がつながらない会社に共通する3つの症状</a:t>
@@ -10487,7 +10487,7 @@
                   <a:tcPr marL="91440" marR="91440" marT="45720" marB="45720" anchor="ctr">
                     <a:lnL w="12700" cap="flat" cmpd="sng" algn="ctr">
                       <a:solidFill>
-                        <a:srgbClr val="BFD6DA"/>
+                        <a:srgbClr val="D9DDE3"/>
                       </a:solidFill>
                       <a:prstDash val="solid"/>
                       <a:round/>
@@ -10496,7 +10496,7 @@
                     </a:lnL>
                     <a:lnR w="12700" cap="flat" cmpd="sng" algn="ctr">
                       <a:solidFill>
-                        <a:srgbClr val="BFD6DA"/>
+                        <a:srgbClr val="D9DDE3"/>
                       </a:solidFill>
                       <a:prstDash val="solid"/>
                       <a:round/>
@@ -10505,7 +10505,7 @@
                     </a:lnR>
                     <a:lnT w="12700" cap="flat" cmpd="sng" algn="ctr">
                       <a:solidFill>
-                        <a:srgbClr val="BFD6DA"/>
+                        <a:srgbClr val="D9DDE3"/>
                       </a:solidFill>
                       <a:prstDash val="solid"/>
                       <a:round/>
@@ -10514,7 +10514,7 @@
                     </a:lnT>
                     <a:lnB w="12700" cap="flat" cmpd="sng" algn="ctr">
                       <a:solidFill>
-                        <a:srgbClr val="BFD6DA"/>
+                        <a:srgbClr val="D9DDE3"/>
                       </a:solidFill>
                       <a:prstDash val="solid"/>
                       <a:round/>
@@ -10537,7 +10537,7 @@
                       <a:r>
                         <a:rPr lang="en-US" sz="1300" dirty="0">
                           <a:solidFill>
-                            <a:srgbClr val="22313A"/>
+                            <a:srgbClr val="333333"/>
                           </a:solidFill>
                         </a:rPr>
                         <a:t>IT戦略 策定、IT戦略 経営戦略</a:t>
@@ -10548,7 +10548,7 @@
                   <a:tcPr marL="91440" marR="91440" marT="45720" marB="45720" anchor="ctr">
                     <a:lnL w="12700" cap="flat" cmpd="sng" algn="ctr">
                       <a:solidFill>
-                        <a:srgbClr val="BFD6DA"/>
+                        <a:srgbClr val="D9DDE3"/>
                       </a:solidFill>
                       <a:prstDash val="solid"/>
                       <a:round/>
@@ -10557,7 +10557,7 @@
                     </a:lnL>
                     <a:lnR w="12700" cap="flat" cmpd="sng" algn="ctr">
                       <a:solidFill>
-                        <a:srgbClr val="BFD6DA"/>
+                        <a:srgbClr val="D9DDE3"/>
                       </a:solidFill>
                       <a:prstDash val="solid"/>
                       <a:round/>
@@ -10566,7 +10566,7 @@
                     </a:lnR>
                     <a:lnT w="12700" cap="flat" cmpd="sng" algn="ctr">
                       <a:solidFill>
-                        <a:srgbClr val="BFD6DA"/>
+                        <a:srgbClr val="D9DDE3"/>
                       </a:solidFill>
                       <a:prstDash val="solid"/>
                       <a:round/>
@@ -10575,7 +10575,7 @@
                     </a:lnT>
                     <a:lnB w="12700" cap="flat" cmpd="sng" algn="ctr">
                       <a:solidFill>
-                        <a:srgbClr val="BFD6DA"/>
+                        <a:srgbClr val="D9DDE3"/>
                       </a:solidFill>
                       <a:prstDash val="solid"/>
                       <a:round/>
@@ -10600,7 +10600,7 @@
                       <a:r>
                         <a:rPr lang="en-US" sz="1300" dirty="0">
                           <a:solidFill>
-                            <a:srgbClr val="22313A"/>
+                            <a:srgbClr val="333333"/>
                           </a:solidFill>
                         </a:rPr>
                         <a:t>α</a:t>
@@ -10611,7 +10611,7 @@
                   <a:tcPr marL="91440" marR="91440" marT="45720" marB="45720" anchor="ctr">
                     <a:lnL w="12700" cap="flat" cmpd="sng" algn="ctr">
                       <a:solidFill>
-                        <a:srgbClr val="BFD6DA"/>
+                        <a:srgbClr val="D9DDE3"/>
                       </a:solidFill>
                       <a:prstDash val="solid"/>
                       <a:round/>
@@ -10620,7 +10620,7 @@
                     </a:lnL>
                     <a:lnR w="12700" cap="flat" cmpd="sng" algn="ctr">
                       <a:solidFill>
-                        <a:srgbClr val="BFD6DA"/>
+                        <a:srgbClr val="D9DDE3"/>
                       </a:solidFill>
                       <a:prstDash val="solid"/>
                       <a:round/>
@@ -10629,7 +10629,7 @@
                     </a:lnR>
                     <a:lnT w="12700" cap="flat" cmpd="sng" algn="ctr">
                       <a:solidFill>
-                        <a:srgbClr val="BFD6DA"/>
+                        <a:srgbClr val="D9DDE3"/>
                       </a:solidFill>
                       <a:prstDash val="solid"/>
                       <a:round/>
@@ -10638,7 +10638,7 @@
                     </a:lnT>
                     <a:lnB w="12700" cap="flat" cmpd="sng" algn="ctr">
                       <a:solidFill>
-                        <a:srgbClr val="BFD6DA"/>
+                        <a:srgbClr val="D9DDE3"/>
                       </a:solidFill>
                       <a:prstDash val="solid"/>
                       <a:round/>
@@ -10661,7 +10661,7 @@
                       <a:r>
                         <a:rPr lang="en-US" sz="1300" b="1" dirty="0">
                           <a:solidFill>
-                            <a:srgbClr val="22313A"/>
+                            <a:srgbClr val="333333"/>
                           </a:solidFill>
                         </a:rPr>
                         <a:t>全体</a:t>
@@ -10672,7 +10672,7 @@
                   <a:tcPr marL="91440" marR="91440" marT="45720" marB="45720" anchor="ctr">
                     <a:lnL w="12700" cap="flat" cmpd="sng" algn="ctr">
                       <a:solidFill>
-                        <a:srgbClr val="BFD6DA"/>
+                        <a:srgbClr val="D9DDE3"/>
                       </a:solidFill>
                       <a:prstDash val="solid"/>
                       <a:round/>
@@ -10681,7 +10681,7 @@
                     </a:lnL>
                     <a:lnR w="12700" cap="flat" cmpd="sng" algn="ctr">
                       <a:solidFill>
-                        <a:srgbClr val="BFD6DA"/>
+                        <a:srgbClr val="D9DDE3"/>
                       </a:solidFill>
                       <a:prstDash val="solid"/>
                       <a:round/>
@@ -10690,7 +10690,7 @@
                     </a:lnR>
                     <a:lnT w="12700" cap="flat" cmpd="sng" algn="ctr">
                       <a:solidFill>
-                        <a:srgbClr val="BFD6DA"/>
+                        <a:srgbClr val="D9DDE3"/>
                       </a:solidFill>
                       <a:prstDash val="solid"/>
                       <a:round/>
@@ -10699,7 +10699,7 @@
                     </a:lnT>
                     <a:lnB w="12700" cap="flat" cmpd="sng" algn="ctr">
                       <a:solidFill>
-                        <a:srgbClr val="BFD6DA"/>
+                        <a:srgbClr val="D9DDE3"/>
                       </a:solidFill>
                       <a:prstDash val="solid"/>
                       <a:round/>
@@ -10722,7 +10722,7 @@
                       <a:r>
                         <a:rPr lang="en-US" sz="1300" dirty="0">
                           <a:solidFill>
-                            <a:srgbClr val="22313A"/>
+                            <a:srgbClr val="333333"/>
                           </a:solidFill>
                         </a:rPr>
                         <a:t>「IT診断」とは何か：やること、期間、費用感の考え方</a:t>
@@ -10733,7 +10733,7 @@
                   <a:tcPr marL="91440" marR="91440" marT="45720" marB="45720" anchor="ctr">
                     <a:lnL w="12700" cap="flat" cmpd="sng" algn="ctr">
                       <a:solidFill>
-                        <a:srgbClr val="BFD6DA"/>
+                        <a:srgbClr val="D9DDE3"/>
                       </a:solidFill>
                       <a:prstDash val="solid"/>
                       <a:round/>
@@ -10742,7 +10742,7 @@
                     </a:lnL>
                     <a:lnR w="12700" cap="flat" cmpd="sng" algn="ctr">
                       <a:solidFill>
-                        <a:srgbClr val="BFD6DA"/>
+                        <a:srgbClr val="D9DDE3"/>
                       </a:solidFill>
                       <a:prstDash val="solid"/>
                       <a:round/>
@@ -10751,7 +10751,7 @@
                     </a:lnR>
                     <a:lnT w="12700" cap="flat" cmpd="sng" algn="ctr">
                       <a:solidFill>
-                        <a:srgbClr val="BFD6DA"/>
+                        <a:srgbClr val="D9DDE3"/>
                       </a:solidFill>
                       <a:prstDash val="solid"/>
                       <a:round/>
@@ -10760,7 +10760,7 @@
                     </a:lnT>
                     <a:lnB w="12700" cap="flat" cmpd="sng" algn="ctr">
                       <a:solidFill>
-                        <a:srgbClr val="BFD6DA"/>
+                        <a:srgbClr val="D9DDE3"/>
                       </a:solidFill>
                       <a:prstDash val="solid"/>
                       <a:round/>
@@ -10783,7 +10783,7 @@
                       <a:r>
                         <a:rPr lang="en-US" sz="1300" dirty="0">
                           <a:solidFill>
-                            <a:srgbClr val="22313A"/>
+                            <a:srgbClr val="333333"/>
                           </a:solidFill>
                         </a:rPr>
                         <a:t>IT診断 とは、IT診断 コンサル</a:t>
@@ -10794,7 +10794,7 @@
                   <a:tcPr marL="91440" marR="91440" marT="45720" marB="45720" anchor="ctr">
                     <a:lnL w="12700" cap="flat" cmpd="sng" algn="ctr">
                       <a:solidFill>
-                        <a:srgbClr val="BFD6DA"/>
+                        <a:srgbClr val="D9DDE3"/>
                       </a:solidFill>
                       <a:prstDash val="solid"/>
                       <a:round/>
@@ -10803,7 +10803,7 @@
                     </a:lnL>
                     <a:lnR w="12700" cap="flat" cmpd="sng" algn="ctr">
                       <a:solidFill>
-                        <a:srgbClr val="BFD6DA"/>
+                        <a:srgbClr val="D9DDE3"/>
                       </a:solidFill>
                       <a:prstDash val="solid"/>
                       <a:round/>
@@ -10812,7 +10812,7 @@
                     </a:lnR>
                     <a:lnT w="12700" cap="flat" cmpd="sng" algn="ctr">
                       <a:solidFill>
-                        <a:srgbClr val="BFD6DA"/>
+                        <a:srgbClr val="D9DDE3"/>
                       </a:solidFill>
                       <a:prstDash val="solid"/>
                       <a:round/>
@@ -10821,7 +10821,7 @@
                     </a:lnT>
                     <a:lnB w="12700" cap="flat" cmpd="sng" algn="ctr">
                       <a:solidFill>
-                        <a:srgbClr val="BFD6DA"/>
+                        <a:srgbClr val="D9DDE3"/>
                       </a:solidFill>
                       <a:prstDash val="solid"/>
                       <a:round/>
@@ -10971,7 +10971,7 @@
             <a:r>
               <a:rPr lang="en-US" sz="2800" b="1" dirty="0">
                 <a:solidFill>
-                  <a:schemeClr val="tx2"/>
+                  <a:schemeClr val="tx1"/>
                 </a:solidFill>
               </a:rPr>
               <a:t>進め方：リスク軸のコラムから先行して拡充する</a:t>
@@ -11956,40 +11956,40 @@
   <a:themeElements>
     <a:clrScheme name="DBJ IT Shindan Proposal">
       <a:dk1>
-        <a:srgbClr val="22313A"/>
+        <a:srgbClr val="333333"/>
       </a:dk1>
       <a:lt1>
         <a:srgbClr val="FFFFFF"/>
       </a:lt1>
       <a:dk2>
-        <a:srgbClr val="0B4F5C"/>
+        <a:srgbClr val="1F3A5F"/>
       </a:dk2>
       <a:lt2>
-        <a:srgbClr val="EEF4F5"/>
+        <a:srgbClr val="F4F6F9"/>
       </a:lt2>
       <a:accent1>
-        <a:srgbClr val="0B7285"/>
+        <a:srgbClr val="1F3A5F"/>
       </a:accent1>
       <a:accent2>
-        <a:srgbClr val="E8A33D"/>
+        <a:srgbClr val="5B7399"/>
       </a:accent2>
       <a:accent3>
-        <a:srgbClr val="2E8B6A"/>
+        <a:srgbClr val="D5DCE8"/>
       </a:accent3>
       <a:accent4>
-        <a:srgbClr val="C8473D"/>
+        <a:srgbClr val="333333"/>
       </a:accent4>
       <a:accent5>
-        <a:srgbClr val="6B7C85"/>
+        <a:srgbClr val="6B7280"/>
       </a:accent5>
       <a:accent6>
-        <a:srgbClr val="BFD6DA"/>
+        <a:srgbClr val="D9DDE3"/>
       </a:accent6>
       <a:hlink>
-        <a:srgbClr val="0B7285"/>
+        <a:srgbClr val="1F3A5F"/>
       </a:hlink>
       <a:folHlink>
-        <a:srgbClr val="6B7C85"/>
+        <a:srgbClr val="6B7280"/>
       </a:folHlink>
     </a:clrScheme>
     <a:fontScheme name="DBJ IT Shindan Proposal">

</xml_diff>

<commit_message>
Rework usage-flow slide, add keyword volumes, show total score with breakdown
Co-Authored-By: Claude Sonnet 5.5 <noreply@anthropic.com>
Claude-Session: https://claude.ai/code/session_017WPoaJyboL7hHVgWMjXgCi
</commit_message>
<xml_diff>
--- a/dbj_it_shindan_proposal.pptx
+++ b/dbj_it_shindan_proposal.pptx
@@ -117,31 +117,31 @@
   <p:extLst>
     <p:ext uri="{521415D9-36F7-43E2-AB2F-B90AF26B5E84}">
       <p14:sectionLst xmlns:p14="http://schemas.microsoft.com/office/powerpoint/2010/main">
-        <p14:section name="導入" id="{5b5dd43f-7386-0bca-7c2e-f9ecd7508ab8}">
+        <p14:section name="導入" id="{34772c53-1984-1d0f-a0b9-0543bf0e1f9c}">
           <p14:sldIdLst>
             <p14:sldId id="256"/>
           </p14:sldIdLst>
         </p14:section>
-        <p14:section name="狙いと全体像" id="{988229a7-37aa-a072-0233-39cfb54a0953}">
+        <p14:section name="狙いと全体像" id="{9152ba63-cffb-ca52-7b04-0f6db39af472}">
           <p14:sldIdLst>
             <p14:sldId id="257"/>
             <p14:sldId id="258"/>
             <p14:sldId id="259"/>
           </p14:sldIdLst>
         </p14:section>
-        <p14:section name="ホワイトペーパー" id="{0e813fab-c796-ab17-6f08-d560cc924c90}">
+        <p14:section name="ホワイトペーパー" id="{2be714e2-0fa6-385f-671e-4b6b1eced715}">
           <p14:sldIdLst>
             <p14:sldId id="260"/>
             <p14:sldId id="261"/>
             <p14:sldId id="262"/>
           </p14:sldIdLst>
         </p14:section>
-        <p14:section name="流入コラム" id="{68d6149b-3ca0-41bc-3c00-2de65ab1dfc8}">
+        <p14:section name="流入コラム" id="{515d5a94-9a0c-415e-df72-bcb9e2290c73}">
           <p14:sldIdLst>
             <p14:sldId id="263"/>
           </p14:sldIdLst>
         </p14:section>
-        <p14:section name="進め方" id="{bb65ad8d-19da-1e64-2e6d-63d575ba9fc7}">
+        <p14:section name="進め方" id="{62510c81-a749-cfd4-cad2-3db8659a7f21}">
           <p14:sldIdLst>
             <p14:sldId id="264"/>
             <p14:sldId id="265"/>
@@ -3988,7 +3988,7 @@
                   <a:schemeClr val="tx1"/>
                 </a:solidFill>
               </a:rPr>
-              <a:t>コラムからWP、商談までを一本の導線でつなぐ</a:t>
+              <a:t>コンテンツの使い方：Webと営業、2つの入口からIT診断へ</a:t>
             </a:r>
             <a:endParaRPr lang="en-US" sz="2800" dirty="0"/>
           </a:p>
@@ -3996,14 +3996,89 @@
       </p:sp>
       <p:sp>
         <p:nvSpPr>
-          <p:cNvPr id="3" name="Step"/>
+          <p:cNvPr id="3" name="Lane"/>
           <p:cNvSpPr/>
           <p:nvPr/>
         </p:nvSpPr>
         <p:spPr>
           <a:xfrm>
-            <a:off x="548640" y="1737360"/>
-            <a:ext cx="2560320" cy="3291840"/>
+            <a:off x="548640" y="1463040"/>
+            <a:ext cx="1554480" cy="1737360"/>
+          </a:xfrm>
+          <a:prstGeom prst="rect">
+            <a:avLst/>
+          </a:prstGeom>
+          <a:solidFill>
+            <a:schemeClr val="accent1"/>
+          </a:solidFill>
+          <a:ln w="12700">
+            <a:solidFill>
+              <a:schemeClr val="accent1"/>
+            </a:solidFill>
+            <a:prstDash val="solid"/>
+          </a:ln>
+        </p:spPr>
+      </p:sp>
+      <p:sp>
+        <p:nvSpPr>
+          <p:cNvPr id="4" name="Text 2"/>
+          <p:cNvSpPr txBox="1"/>
+          <p:nvPr/>
+        </p:nvSpPr>
+        <p:spPr>
+          <a:xfrm>
+            <a:off x="548640" y="1463040"/>
+            <a:ext cx="1554480" cy="1737360"/>
+          </a:xfrm>
+          <a:prstGeom prst="rect">
+            <a:avLst/>
+          </a:prstGeom>
+          <a:noFill/>
+          <a:ln/>
+        </p:spPr>
+        <p:txBody>
+          <a:bodyPr wrap="square" lIns="635" tIns="635" rIns="635" bIns="635" rtlCol="0" anchor="ctr"/>
+          <a:lstStyle/>
+          <a:p>
+            <a:pPr algn="ctr" indent="0" marL="0">
+              <a:buNone/>
+            </a:pPr>
+            <a:r>
+              <a:rPr lang="en-US" sz="2200" b="1" dirty="0">
+                <a:solidFill>
+                  <a:schemeClr val="bg1"/>
+                </a:solidFill>
+              </a:rPr>
+              <a:t>Web</a:t>
+            </a:r>
+            <a:endParaRPr lang="en-US" sz="2200" dirty="0"/>
+          </a:p>
+          <a:p>
+            <a:pPr algn="ctr" indent="0" marL="0">
+              <a:buNone/>
+            </a:pPr>
+            <a:r>
+              <a:rPr lang="en-US" sz="1200" dirty="0">
+                <a:solidFill>
+                  <a:schemeClr val="bg1"/>
+                </a:solidFill>
+              </a:rPr>
+              <a:t>検索・メルマガ</a:t>
+            </a:r>
+            <a:endParaRPr lang="en-US" sz="2200" dirty="0"/>
+          </a:p>
+        </p:txBody>
+      </p:sp>
+      <p:sp>
+        <p:nvSpPr>
+          <p:cNvPr id="5" name="Step"/>
+          <p:cNvSpPr/>
+          <p:nvPr/>
+        </p:nvSpPr>
+        <p:spPr>
+          <a:xfrm>
+            <a:off x="2331720" y="1463040"/>
+            <a:ext cx="2148840" cy="1737360"/>
           </a:xfrm>
           <a:prstGeom prst="rect">
             <a:avLst/>
@@ -4021,16 +4096,332 @@
       </p:sp>
       <p:sp>
         <p:nvSpPr>
-          <p:cNvPr id="4" name="Badge"/>
+          <p:cNvPr id="6" name="Text 4"/>
+          <p:cNvSpPr txBox="1"/>
+          <p:nvPr/>
+        </p:nvSpPr>
+        <p:spPr>
+          <a:xfrm>
+            <a:off x="2514600" y="1600200"/>
+            <a:ext cx="1783080" cy="548640"/>
+          </a:xfrm>
+          <a:prstGeom prst="rect">
+            <a:avLst/>
+          </a:prstGeom>
+          <a:noFill/>
+          <a:ln/>
+        </p:spPr>
+        <p:txBody>
+          <a:bodyPr wrap="square" lIns="0" tIns="0" rIns="0" bIns="0" rtlCol="0" anchor="ctr"/>
+          <a:lstStyle/>
+          <a:p>
+            <a:pPr indent="0" marL="0">
+              <a:buNone/>
+            </a:pPr>
+            <a:r>
+              <a:rPr lang="en-US" sz="1600" b="1" dirty="0">
+                <a:solidFill>
+                  <a:schemeClr val="tx1"/>
+                </a:solidFill>
+              </a:rPr>
+              <a:t>コラム／メルマガ</a:t>
+            </a:r>
+            <a:endParaRPr lang="en-US" sz="1600" dirty="0"/>
+          </a:p>
+        </p:txBody>
+      </p:sp>
+      <p:sp>
+        <p:nvSpPr>
+          <p:cNvPr id="7" name="Text 5"/>
+          <p:cNvSpPr txBox="1"/>
+          <p:nvPr/>
+        </p:nvSpPr>
+        <p:spPr>
+          <a:xfrm>
+            <a:off x="2514600" y="2194560"/>
+            <a:ext cx="1783080" cy="914400"/>
+          </a:xfrm>
+          <a:prstGeom prst="rect">
+            <a:avLst/>
+          </a:prstGeom>
+          <a:noFill/>
+          <a:ln/>
+        </p:spPr>
+        <p:txBody>
+          <a:bodyPr wrap="square" lIns="0" tIns="0" rIns="0" bIns="0" rtlCol="0" anchor="t"/>
+          <a:lstStyle/>
+          <a:p>
+            <a:pPr indent="0" marL="0">
+              <a:buNone/>
+            </a:pPr>
+            <a:r>
+              <a:rPr lang="en-US" sz="1300" dirty="0">
+                <a:solidFill>
+                  <a:schemeClr val="tx1"/>
+                </a:solidFill>
+              </a:rPr>
+              <a:t>コラムは検索で、メルマガは既存リードに届ける</a:t>
+            </a:r>
+            <a:endParaRPr lang="en-US" sz="1300" dirty="0"/>
+          </a:p>
+        </p:txBody>
+      </p:sp>
+      <p:sp>
+        <p:nvSpPr>
+          <p:cNvPr id="8" name="Arrow"/>
           <p:cNvSpPr/>
           <p:nvPr/>
         </p:nvSpPr>
         <p:spPr>
           <a:xfrm>
-            <a:off x="777240" y="1965960"/>
-            <a:ext cx="548640" cy="548640"/>
-          </a:xfrm>
-          <a:prstGeom prst="ellipse">
+            <a:off x="4526280" y="2176272"/>
+            <a:ext cx="246888" cy="365760"/>
+          </a:xfrm>
+          <a:prstGeom prst="rightArrow">
+            <a:avLst/>
+          </a:prstGeom>
+          <a:solidFill>
+            <a:schemeClr val="accent5"/>
+          </a:solidFill>
+          <a:ln w="12700">
+            <a:solidFill>
+              <a:schemeClr val="accent5"/>
+            </a:solidFill>
+            <a:prstDash val="solid"/>
+          </a:ln>
+        </p:spPr>
+      </p:sp>
+      <p:sp>
+        <p:nvSpPr>
+          <p:cNvPr id="9" name="Step"/>
+          <p:cNvSpPr/>
+          <p:nvPr/>
+        </p:nvSpPr>
+        <p:spPr>
+          <a:xfrm>
+            <a:off x="4800600" y="1463040"/>
+            <a:ext cx="2148840" cy="1737360"/>
+          </a:xfrm>
+          <a:prstGeom prst="rect">
+            <a:avLst/>
+          </a:prstGeom>
+          <a:solidFill>
+            <a:schemeClr val="bg2"/>
+          </a:solidFill>
+          <a:ln w="12700">
+            <a:solidFill>
+              <a:schemeClr val="bg2"/>
+            </a:solidFill>
+            <a:prstDash val="solid"/>
+          </a:ln>
+        </p:spPr>
+      </p:sp>
+      <p:sp>
+        <p:nvSpPr>
+          <p:cNvPr id="10" name="Text 8"/>
+          <p:cNvSpPr txBox="1"/>
+          <p:nvPr/>
+        </p:nvSpPr>
+        <p:spPr>
+          <a:xfrm>
+            <a:off x="4983480" y="1600200"/>
+            <a:ext cx="1783080" cy="548640"/>
+          </a:xfrm>
+          <a:prstGeom prst="rect">
+            <a:avLst/>
+          </a:prstGeom>
+          <a:noFill/>
+          <a:ln/>
+        </p:spPr>
+        <p:txBody>
+          <a:bodyPr wrap="square" lIns="0" tIns="0" rIns="0" bIns="0" rtlCol="0" anchor="ctr"/>
+          <a:lstStyle/>
+          <a:p>
+            <a:pPr indent="0" marL="0">
+              <a:buNone/>
+            </a:pPr>
+            <a:r>
+              <a:rPr lang="en-US" sz="1600" b="1" dirty="0">
+                <a:solidFill>
+                  <a:schemeClr val="tx1"/>
+                </a:solidFill>
+              </a:rPr>
+              <a:t>WPダウンロード</a:t>
+            </a:r>
+            <a:endParaRPr lang="en-US" sz="1600" dirty="0"/>
+          </a:p>
+        </p:txBody>
+      </p:sp>
+      <p:sp>
+        <p:nvSpPr>
+          <p:cNvPr id="11" name="Text 9"/>
+          <p:cNvSpPr txBox="1"/>
+          <p:nvPr/>
+        </p:nvSpPr>
+        <p:spPr>
+          <a:xfrm>
+            <a:off x="4983480" y="2194560"/>
+            <a:ext cx="1783080" cy="914400"/>
+          </a:xfrm>
+          <a:prstGeom prst="rect">
+            <a:avLst/>
+          </a:prstGeom>
+          <a:noFill/>
+          <a:ln/>
+        </p:spPr>
+        <p:txBody>
+          <a:bodyPr wrap="square" lIns="0" tIns="0" rIns="0" bIns="0" rtlCol="0" anchor="t"/>
+          <a:lstStyle/>
+          <a:p>
+            <a:pPr indent="0" marL="0">
+              <a:buNone/>
+            </a:pPr>
+            <a:r>
+              <a:rPr lang="en-US" sz="1300" dirty="0">
+                <a:solidFill>
+                  <a:schemeClr val="tx1"/>
+                </a:solidFill>
+              </a:rPr>
+              <a:t>10分のセルフチェックで現在地を知る</a:t>
+            </a:r>
+            <a:endParaRPr lang="en-US" sz="1300" dirty="0"/>
+          </a:p>
+        </p:txBody>
+      </p:sp>
+      <p:sp>
+        <p:nvSpPr>
+          <p:cNvPr id="12" name="Arrow"/>
+          <p:cNvSpPr/>
+          <p:nvPr/>
+        </p:nvSpPr>
+        <p:spPr>
+          <a:xfrm>
+            <a:off x="6995160" y="2176272"/>
+            <a:ext cx="246888" cy="365760"/>
+          </a:xfrm>
+          <a:prstGeom prst="rightArrow">
+            <a:avLst/>
+          </a:prstGeom>
+          <a:solidFill>
+            <a:schemeClr val="accent5"/>
+          </a:solidFill>
+          <a:ln w="12700">
+            <a:solidFill>
+              <a:schemeClr val="accent5"/>
+            </a:solidFill>
+            <a:prstDash val="solid"/>
+          </a:ln>
+        </p:spPr>
+      </p:sp>
+      <p:sp>
+        <p:nvSpPr>
+          <p:cNvPr id="13" name="Step"/>
+          <p:cNvSpPr/>
+          <p:nvPr/>
+        </p:nvSpPr>
+        <p:spPr>
+          <a:xfrm>
+            <a:off x="7269480" y="1463040"/>
+            <a:ext cx="2148840" cy="1737360"/>
+          </a:xfrm>
+          <a:prstGeom prst="rect">
+            <a:avLst/>
+          </a:prstGeom>
+          <a:solidFill>
+            <a:schemeClr val="bg2"/>
+          </a:solidFill>
+          <a:ln w="12700">
+            <a:solidFill>
+              <a:schemeClr val="bg2"/>
+            </a:solidFill>
+            <a:prstDash val="solid"/>
+          </a:ln>
+        </p:spPr>
+      </p:sp>
+      <p:sp>
+        <p:nvSpPr>
+          <p:cNvPr id="14" name="Text 12"/>
+          <p:cNvSpPr txBox="1"/>
+          <p:nvPr/>
+        </p:nvSpPr>
+        <p:spPr>
+          <a:xfrm>
+            <a:off x="7452360" y="1600200"/>
+            <a:ext cx="1783080" cy="548640"/>
+          </a:xfrm>
+          <a:prstGeom prst="rect">
+            <a:avLst/>
+          </a:prstGeom>
+          <a:noFill/>
+          <a:ln/>
+        </p:spPr>
+        <p:txBody>
+          <a:bodyPr wrap="square" lIns="0" tIns="0" rIns="0" bIns="0" rtlCol="0" anchor="ctr"/>
+          <a:lstStyle/>
+          <a:p>
+            <a:pPr indent="0" marL="0">
+              <a:buNone/>
+            </a:pPr>
+            <a:r>
+              <a:rPr lang="en-US" sz="1600" b="1" dirty="0">
+                <a:solidFill>
+                  <a:schemeClr val="tx1"/>
+                </a:solidFill>
+              </a:rPr>
+              <a:t>問い合わせ</a:t>
+            </a:r>
+            <a:endParaRPr lang="en-US" sz="1600" dirty="0"/>
+          </a:p>
+        </p:txBody>
+      </p:sp>
+      <p:sp>
+        <p:nvSpPr>
+          <p:cNvPr id="15" name="Text 13"/>
+          <p:cNvSpPr txBox="1"/>
+          <p:nvPr/>
+        </p:nvSpPr>
+        <p:spPr>
+          <a:xfrm>
+            <a:off x="7452360" y="2194560"/>
+            <a:ext cx="1783080" cy="914400"/>
+          </a:xfrm>
+          <a:prstGeom prst="rect">
+            <a:avLst/>
+          </a:prstGeom>
+          <a:noFill/>
+          <a:ln/>
+        </p:spPr>
+        <p:txBody>
+          <a:bodyPr wrap="square" lIns="0" tIns="0" rIns="0" bIns="0" rtlCol="0" anchor="t"/>
+          <a:lstStyle/>
+          <a:p>
+            <a:pPr indent="0" marL="0">
+              <a:buNone/>
+            </a:pPr>
+            <a:r>
+              <a:rPr lang="en-US" sz="1300" dirty="0">
+                <a:solidFill>
+                  <a:schemeClr val="tx1"/>
+                </a:solidFill>
+              </a:rPr>
+              <a:t>結果をもとに問い合わせ、または営業からフォロー</a:t>
+            </a:r>
+            <a:endParaRPr lang="en-US" sz="1300" dirty="0"/>
+          </a:p>
+        </p:txBody>
+      </p:sp>
+      <p:sp>
+        <p:nvSpPr>
+          <p:cNvPr id="16" name="Lane"/>
+          <p:cNvSpPr/>
+          <p:nvPr/>
+        </p:nvSpPr>
+        <p:spPr>
+          <a:xfrm>
+            <a:off x="548640" y="3383280"/>
+            <a:ext cx="1554480" cy="1737360"/>
+          </a:xfrm>
+          <a:prstGeom prst="rect">
             <a:avLst/>
           </a:prstGeom>
           <a:solidFill>
@@ -4046,14 +4437,89 @@
       </p:sp>
       <p:sp>
         <p:nvSpPr>
-          <p:cNvPr id="5" name="Text 3"/>
-          <p:cNvSpPr txBox="1"/>
-          <p:nvPr/>
-        </p:nvSpPr>
-        <p:spPr>
-          <a:xfrm>
-            <a:off x="777240" y="1965960"/>
-            <a:ext cx="548640" cy="548640"/>
+          <p:cNvPr id="17" name="Text 15"/>
+          <p:cNvSpPr txBox="1"/>
+          <p:nvPr/>
+        </p:nvSpPr>
+        <p:spPr>
+          <a:xfrm>
+            <a:off x="548640" y="3383280"/>
+            <a:ext cx="1554480" cy="1737360"/>
+          </a:xfrm>
+          <a:prstGeom prst="rect">
+            <a:avLst/>
+          </a:prstGeom>
+          <a:noFill/>
+          <a:ln/>
+        </p:spPr>
+        <p:txBody>
+          <a:bodyPr wrap="square" lIns="635" tIns="635" rIns="635" bIns="635" rtlCol="0" anchor="ctr"/>
+          <a:lstStyle/>
+          <a:p>
+            <a:pPr algn="ctr" indent="0" marL="0">
+              <a:buNone/>
+            </a:pPr>
+            <a:r>
+              <a:rPr lang="en-US" sz="2200" b="1" dirty="0">
+                <a:solidFill>
+                  <a:schemeClr val="bg1"/>
+                </a:solidFill>
+              </a:rPr>
+              <a:t>営業</a:t>
+            </a:r>
+            <a:endParaRPr lang="en-US" sz="2200" dirty="0"/>
+          </a:p>
+          <a:p>
+            <a:pPr algn="ctr" indent="0" marL="0">
+              <a:buNone/>
+            </a:pPr>
+            <a:r>
+              <a:rPr lang="en-US" sz="1200" dirty="0">
+                <a:solidFill>
+                  <a:schemeClr val="bg1"/>
+                </a:solidFill>
+              </a:rPr>
+              <a:t>商談・営業トーク</a:t>
+            </a:r>
+            <a:endParaRPr lang="en-US" sz="2200" dirty="0"/>
+          </a:p>
+        </p:txBody>
+      </p:sp>
+      <p:sp>
+        <p:nvSpPr>
+          <p:cNvPr id="18" name="Step"/>
+          <p:cNvSpPr/>
+          <p:nvPr/>
+        </p:nvSpPr>
+        <p:spPr>
+          <a:xfrm>
+            <a:off x="2331720" y="3383280"/>
+            <a:ext cx="2148840" cy="1737360"/>
+          </a:xfrm>
+          <a:prstGeom prst="rect">
+            <a:avLst/>
+          </a:prstGeom>
+          <a:solidFill>
+            <a:schemeClr val="bg2"/>
+          </a:solidFill>
+          <a:ln w="12700">
+            <a:solidFill>
+              <a:schemeClr val="bg2"/>
+            </a:solidFill>
+            <a:prstDash val="solid"/>
+          </a:ln>
+        </p:spPr>
+      </p:sp>
+      <p:sp>
+        <p:nvSpPr>
+          <p:cNvPr id="19" name="Text 17"/>
+          <p:cNvSpPr txBox="1"/>
+          <p:nvPr/>
+        </p:nvSpPr>
+        <p:spPr>
+          <a:xfrm>
+            <a:off x="2514600" y="3520440"/>
+            <a:ext cx="1783080" cy="548640"/>
           </a:xfrm>
           <a:prstGeom prst="rect">
             <a:avLst/>
@@ -4065,31 +4531,31 @@
           <a:bodyPr wrap="square" lIns="0" tIns="0" rIns="0" bIns="0" rtlCol="0" anchor="ctr"/>
           <a:lstStyle/>
           <a:p>
-            <a:pPr algn="ctr" indent="0" marL="0">
-              <a:buNone/>
-            </a:pPr>
-            <a:r>
-              <a:rPr lang="en-US" sz="1800" b="1" dirty="0">
-                <a:solidFill>
-                  <a:schemeClr val="bg1"/>
-                </a:solidFill>
-              </a:rPr>
-              <a:t>1</a:t>
-            </a:r>
-            <a:endParaRPr lang="en-US" sz="1800" dirty="0"/>
-          </a:p>
-        </p:txBody>
-      </p:sp>
-      <p:sp>
-        <p:nvSpPr>
-          <p:cNvPr id="6" name="Text 4"/>
-          <p:cNvSpPr txBox="1"/>
-          <p:nvPr/>
-        </p:nvSpPr>
-        <p:spPr>
-          <a:xfrm>
-            <a:off x="777240" y="2743200"/>
-            <a:ext cx="2103120" cy="731520"/>
+            <a:pPr indent="0" marL="0">
+              <a:buNone/>
+            </a:pPr>
+            <a:r>
+              <a:rPr lang="en-US" sz="1600" b="1" dirty="0">
+                <a:solidFill>
+                  <a:schemeClr val="tx1"/>
+                </a:solidFill>
+              </a:rPr>
+              <a:t>商談・営業トーク</a:t>
+            </a:r>
+            <a:endParaRPr lang="en-US" sz="1600" dirty="0"/>
+          </a:p>
+        </p:txBody>
+      </p:sp>
+      <p:sp>
+        <p:nvSpPr>
+          <p:cNvPr id="20" name="Text 18"/>
+          <p:cNvSpPr txBox="1"/>
+          <p:nvPr/>
+        </p:nvSpPr>
+        <p:spPr>
+          <a:xfrm>
+            <a:off x="2514600" y="4114800"/>
+            <a:ext cx="1783080" cy="914400"/>
           </a:xfrm>
           <a:prstGeom prst="rect">
             <a:avLst/>
@@ -4105,99 +4571,27 @@
               <a:buNone/>
             </a:pPr>
             <a:r>
-              <a:rPr lang="en-US" sz="1800" b="1" dirty="0">
+              <a:rPr lang="en-US" sz="1300" dirty="0">
                 <a:solidFill>
                   <a:schemeClr val="tx1"/>
                 </a:solidFill>
               </a:rPr>
-              <a:t>コラム</a:t>
-            </a:r>
-            <a:endParaRPr lang="en-US" sz="1800" dirty="0"/>
-          </a:p>
-        </p:txBody>
-      </p:sp>
-      <p:sp>
-        <p:nvSpPr>
-          <p:cNvPr id="7" name="Text 5"/>
-          <p:cNvSpPr txBox="1"/>
-          <p:nvPr/>
-        </p:nvSpPr>
-        <p:spPr>
-          <a:xfrm>
-            <a:off x="777240" y="3520440"/>
-            <a:ext cx="2103120" cy="822960"/>
-          </a:xfrm>
-          <a:prstGeom prst="rect">
-            <a:avLst/>
-          </a:prstGeom>
-          <a:noFill/>
-          <a:ln/>
-        </p:spPr>
-        <p:txBody>
-          <a:bodyPr wrap="square" lIns="0" tIns="0" rIns="0" bIns="0" rtlCol="0" anchor="t"/>
-          <a:lstStyle/>
-          <a:p>
-            <a:pPr indent="0" marL="0">
-              <a:buNone/>
-            </a:pPr>
-            <a:r>
-              <a:rPr lang="en-US" sz="1400" dirty="0">
-                <a:solidFill>
-                  <a:schemeClr val="tx1"/>
-                </a:solidFill>
-              </a:rPr>
-              <a:t>検索・SNSで経営層に出会う</a:t>
-            </a:r>
-            <a:endParaRPr lang="en-US" sz="1400" dirty="0"/>
-          </a:p>
-        </p:txBody>
-      </p:sp>
-      <p:sp>
-        <p:nvSpPr>
-          <p:cNvPr id="8" name="Text 6"/>
-          <p:cNvSpPr txBox="1"/>
-          <p:nvPr/>
-        </p:nvSpPr>
-        <p:spPr>
-          <a:xfrm>
-            <a:off x="777240" y="4389120"/>
-            <a:ext cx="2103120" cy="548640"/>
-          </a:xfrm>
-          <a:prstGeom prst="rect">
-            <a:avLst/>
-          </a:prstGeom>
-          <a:noFill/>
-          <a:ln/>
-        </p:spPr>
-        <p:txBody>
-          <a:bodyPr wrap="square" lIns="0" tIns="0" rIns="0" bIns="0" rtlCol="0" anchor="t"/>
-          <a:lstStyle/>
-          <a:p>
-            <a:pPr indent="0" marL="0">
-              <a:buNone/>
-            </a:pPr>
-            <a:r>
-              <a:rPr lang="en-US" sz="1200" dirty="0">
-                <a:solidFill>
-                  <a:schemeClr val="accent5"/>
-                </a:solidFill>
-              </a:rPr>
-              <a:t>指標：PV、WPへのクリック率</a:t>
-            </a:r>
-            <a:endParaRPr lang="en-US" sz="1200" dirty="0"/>
-          </a:p>
-        </p:txBody>
-      </p:sp>
-      <p:sp>
-        <p:nvSpPr>
-          <p:cNvPr id="9" name="Arrow"/>
+              <a:t>課題のヒアリング中に、WPを紹介する</a:t>
+            </a:r>
+            <a:endParaRPr lang="en-US" sz="1300" dirty="0"/>
+          </a:p>
+        </p:txBody>
+      </p:sp>
+      <p:sp>
+        <p:nvSpPr>
+          <p:cNvPr id="21" name="Arrow"/>
           <p:cNvSpPr/>
           <p:nvPr/>
         </p:nvSpPr>
         <p:spPr>
           <a:xfrm>
-            <a:off x="3127248" y="3200400"/>
-            <a:ext cx="237744" cy="365760"/>
+            <a:off x="4526280" y="4096512"/>
+            <a:ext cx="246888" cy="365760"/>
           </a:xfrm>
           <a:prstGeom prst="rightArrow">
             <a:avLst/>
@@ -4215,14 +4609,14 @@
       </p:sp>
       <p:sp>
         <p:nvSpPr>
-          <p:cNvPr id="10" name="Step"/>
+          <p:cNvPr id="22" name="Step"/>
           <p:cNvSpPr/>
           <p:nvPr/>
         </p:nvSpPr>
         <p:spPr>
           <a:xfrm>
-            <a:off x="3383280" y="1737360"/>
-            <a:ext cx="2560320" cy="3291840"/>
+            <a:off x="4800600" y="3383280"/>
+            <a:ext cx="2148840" cy="1737360"/>
           </a:xfrm>
           <a:prstGeom prst="rect">
             <a:avLst/>
@@ -4240,16 +4634,235 @@
       </p:sp>
       <p:sp>
         <p:nvSpPr>
-          <p:cNvPr id="11" name="Badge"/>
+          <p:cNvPr id="23" name="Text 21"/>
+          <p:cNvSpPr txBox="1"/>
+          <p:nvPr/>
+        </p:nvSpPr>
+        <p:spPr>
+          <a:xfrm>
+            <a:off x="4983480" y="3520440"/>
+            <a:ext cx="1783080" cy="548640"/>
+          </a:xfrm>
+          <a:prstGeom prst="rect">
+            <a:avLst/>
+          </a:prstGeom>
+          <a:noFill/>
+          <a:ln/>
+        </p:spPr>
+        <p:txBody>
+          <a:bodyPr wrap="square" lIns="0" tIns="0" rIns="0" bIns="0" rtlCol="0" anchor="ctr"/>
+          <a:lstStyle/>
+          <a:p>
+            <a:pPr indent="0" marL="0">
+              <a:buNone/>
+            </a:pPr>
+            <a:r>
+              <a:rPr lang="en-US" sz="1600" b="1" dirty="0">
+                <a:solidFill>
+                  <a:schemeClr val="tx1"/>
+                </a:solidFill>
+              </a:rPr>
+              <a:t>WPを一緒に記入</a:t>
+            </a:r>
+            <a:endParaRPr lang="en-US" sz="1600" dirty="0"/>
+          </a:p>
+        </p:txBody>
+      </p:sp>
+      <p:sp>
+        <p:nvSpPr>
+          <p:cNvPr id="24" name="Text 22"/>
+          <p:cNvSpPr txBox="1"/>
+          <p:nvPr/>
+        </p:nvSpPr>
+        <p:spPr>
+          <a:xfrm>
+            <a:off x="4983480" y="4114800"/>
+            <a:ext cx="1783080" cy="914400"/>
+          </a:xfrm>
+          <a:prstGeom prst="rect">
+            <a:avLst/>
+          </a:prstGeom>
+          <a:noFill/>
+          <a:ln/>
+        </p:spPr>
+        <p:txBody>
+          <a:bodyPr wrap="square" lIns="0" tIns="0" rIns="0" bIns="0" rtlCol="0" anchor="t"/>
+          <a:lstStyle/>
+          <a:p>
+            <a:pPr indent="0" marL="0">
+              <a:buNone/>
+            </a:pPr>
+            <a:r>
+              <a:rPr lang="en-US" sz="1300" dirty="0">
+                <a:solidFill>
+                  <a:schemeClr val="tx1"/>
+                </a:solidFill>
+              </a:rPr>
+              <a:t>営業用の版で、その場でチェックする</a:t>
+            </a:r>
+            <a:endParaRPr lang="en-US" sz="1300" dirty="0"/>
+          </a:p>
+        </p:txBody>
+      </p:sp>
+      <p:sp>
+        <p:nvSpPr>
+          <p:cNvPr id="25" name="Arrow"/>
           <p:cNvSpPr/>
           <p:nvPr/>
         </p:nvSpPr>
         <p:spPr>
           <a:xfrm>
-            <a:off x="3611880" y="1965960"/>
-            <a:ext cx="548640" cy="548640"/>
-          </a:xfrm>
-          <a:prstGeom prst="ellipse">
+            <a:off x="6995160" y="4096512"/>
+            <a:ext cx="246888" cy="365760"/>
+          </a:xfrm>
+          <a:prstGeom prst="rightArrow">
+            <a:avLst/>
+          </a:prstGeom>
+          <a:solidFill>
+            <a:schemeClr val="accent5"/>
+          </a:solidFill>
+          <a:ln w="12700">
+            <a:solidFill>
+              <a:schemeClr val="accent5"/>
+            </a:solidFill>
+            <a:prstDash val="solid"/>
+          </a:ln>
+        </p:spPr>
+      </p:sp>
+      <p:sp>
+        <p:nvSpPr>
+          <p:cNvPr id="26" name="Step"/>
+          <p:cNvSpPr/>
+          <p:nvPr/>
+        </p:nvSpPr>
+        <p:spPr>
+          <a:xfrm>
+            <a:off x="7269480" y="3383280"/>
+            <a:ext cx="2148840" cy="1737360"/>
+          </a:xfrm>
+          <a:prstGeom prst="rect">
+            <a:avLst/>
+          </a:prstGeom>
+          <a:solidFill>
+            <a:schemeClr val="bg2"/>
+          </a:solidFill>
+          <a:ln w="12700">
+            <a:solidFill>
+              <a:schemeClr val="bg2"/>
+            </a:solidFill>
+            <a:prstDash val="solid"/>
+          </a:ln>
+        </p:spPr>
+      </p:sp>
+      <p:sp>
+        <p:nvSpPr>
+          <p:cNvPr id="27" name="Text 25"/>
+          <p:cNvSpPr txBox="1"/>
+          <p:nvPr/>
+        </p:nvSpPr>
+        <p:spPr>
+          <a:xfrm>
+            <a:off x="7452360" y="3520440"/>
+            <a:ext cx="1783080" cy="548640"/>
+          </a:xfrm>
+          <a:prstGeom prst="rect">
+            <a:avLst/>
+          </a:prstGeom>
+          <a:noFill/>
+          <a:ln/>
+        </p:spPr>
+        <p:txBody>
+          <a:bodyPr wrap="square" lIns="0" tIns="0" rIns="0" bIns="0" rtlCol="0" anchor="ctr"/>
+          <a:lstStyle/>
+          <a:p>
+            <a:pPr indent="0" marL="0">
+              <a:buNone/>
+            </a:pPr>
+            <a:r>
+              <a:rPr lang="en-US" sz="1600" b="1" dirty="0">
+                <a:solidFill>
+                  <a:schemeClr val="tx1"/>
+                </a:solidFill>
+              </a:rPr>
+              <a:t>結果の読み合わせ</a:t>
+            </a:r>
+            <a:endParaRPr lang="en-US" sz="1600" dirty="0"/>
+          </a:p>
+        </p:txBody>
+      </p:sp>
+      <p:sp>
+        <p:nvSpPr>
+          <p:cNvPr id="28" name="Text 26"/>
+          <p:cNvSpPr txBox="1"/>
+          <p:nvPr/>
+        </p:nvSpPr>
+        <p:spPr>
+          <a:xfrm>
+            <a:off x="7452360" y="4114800"/>
+            <a:ext cx="1783080" cy="914400"/>
+          </a:xfrm>
+          <a:prstGeom prst="rect">
+            <a:avLst/>
+          </a:prstGeom>
+          <a:noFill/>
+          <a:ln/>
+        </p:spPr>
+        <p:txBody>
+          <a:bodyPr wrap="square" lIns="0" tIns="0" rIns="0" bIns="0" rtlCol="0" anchor="t"/>
+          <a:lstStyle/>
+          <a:p>
+            <a:pPr indent="0" marL="0">
+              <a:buNone/>
+            </a:pPr>
+            <a:r>
+              <a:rPr lang="en-US" sz="1300" dirty="0">
+                <a:solidFill>
+                  <a:schemeClr val="tx1"/>
+                </a:solidFill>
+              </a:rPr>
+              <a:t>NOだった項目を30分で一緒に確認</a:t>
+            </a:r>
+            <a:endParaRPr lang="en-US" sz="1300" dirty="0"/>
+          </a:p>
+        </p:txBody>
+      </p:sp>
+      <p:sp>
+        <p:nvSpPr>
+          <p:cNvPr id="29" name="Arrow"/>
+          <p:cNvSpPr/>
+          <p:nvPr/>
+        </p:nvSpPr>
+        <p:spPr>
+          <a:xfrm>
+            <a:off x="9555480" y="3154680"/>
+            <a:ext cx="274320" cy="365760"/>
+          </a:xfrm>
+          <a:prstGeom prst="rightArrow">
+            <a:avLst/>
+          </a:prstGeom>
+          <a:solidFill>
+            <a:schemeClr val="accent5"/>
+          </a:solidFill>
+          <a:ln w="12700">
+            <a:solidFill>
+              <a:schemeClr val="accent5"/>
+            </a:solidFill>
+            <a:prstDash val="solid"/>
+          </a:ln>
+        </p:spPr>
+      </p:sp>
+      <p:sp>
+        <p:nvSpPr>
+          <p:cNvPr id="30" name="Goal"/>
+          <p:cNvSpPr/>
+          <p:nvPr/>
+        </p:nvSpPr>
+        <p:spPr>
+          <a:xfrm>
+            <a:off x="9875520" y="1463040"/>
+            <a:ext cx="1764792" cy="3657600"/>
+          </a:xfrm>
+          <a:prstGeom prst="rect">
             <a:avLst/>
           </a:prstGeom>
           <a:solidFill>
@@ -4265,50 +4878,78 @@
       </p:sp>
       <p:sp>
         <p:nvSpPr>
-          <p:cNvPr id="12" name="Text 10"/>
-          <p:cNvSpPr txBox="1"/>
-          <p:nvPr/>
-        </p:nvSpPr>
-        <p:spPr>
-          <a:xfrm>
-            <a:off x="3611880" y="1965960"/>
-            <a:ext cx="548640" cy="548640"/>
-          </a:xfrm>
-          <a:prstGeom prst="rect">
-            <a:avLst/>
-          </a:prstGeom>
-          <a:noFill/>
-          <a:ln/>
-        </p:spPr>
-        <p:txBody>
-          <a:bodyPr wrap="square" lIns="0" tIns="0" rIns="0" bIns="0" rtlCol="0" anchor="ctr"/>
+          <p:cNvPr id="31" name="Text 29"/>
+          <p:cNvSpPr txBox="1"/>
+          <p:nvPr/>
+        </p:nvSpPr>
+        <p:spPr>
+          <a:xfrm>
+            <a:off x="9875520" y="1463040"/>
+            <a:ext cx="1764792" cy="3657600"/>
+          </a:xfrm>
+          <a:prstGeom prst="rect">
+            <a:avLst/>
+          </a:prstGeom>
+          <a:noFill/>
+          <a:ln/>
+        </p:spPr>
+        <p:txBody>
+          <a:bodyPr wrap="square" lIns="1270" tIns="1270" rIns="1270" bIns="1270" rtlCol="0" anchor="ctr"/>
           <a:lstStyle/>
           <a:p>
             <a:pPr algn="ctr" indent="0" marL="0">
               <a:buNone/>
             </a:pPr>
             <a:r>
-              <a:rPr lang="en-US" sz="1800" b="1" dirty="0">
+              <a:rPr lang="en-US" sz="2000" b="1" dirty="0">
                 <a:solidFill>
                   <a:schemeClr val="bg1"/>
                 </a:solidFill>
               </a:rPr>
-              <a:t>2</a:t>
-            </a:r>
-            <a:endParaRPr lang="en-US" sz="1800" dirty="0"/>
-          </a:p>
-        </p:txBody>
-      </p:sp>
-      <p:sp>
-        <p:nvSpPr>
-          <p:cNvPr id="13" name="Text 11"/>
-          <p:cNvSpPr txBox="1"/>
-          <p:nvPr/>
-        </p:nvSpPr>
-        <p:spPr>
-          <a:xfrm>
-            <a:off x="3611880" y="2743200"/>
-            <a:ext cx="2103120" cy="731520"/>
+              <a:t>IT診断</a:t>
+            </a:r>
+            <a:endParaRPr lang="en-US" sz="2000" dirty="0"/>
+          </a:p>
+          <a:p>
+            <a:pPr algn="ctr" indent="0" marL="0">
+              <a:buNone/>
+            </a:pPr>
+            <a:r>
+              <a:rPr lang="en-US" sz="2000" b="1" dirty="0">
+                <a:solidFill>
+                  <a:schemeClr val="bg1"/>
+                </a:solidFill>
+              </a:rPr>
+              <a:t>サービス</a:t>
+            </a:r>
+            <a:endParaRPr lang="en-US" sz="2000" dirty="0"/>
+          </a:p>
+          <a:p>
+            <a:pPr algn="ctr" indent="0" marL="0">
+              <a:buNone/>
+            </a:pPr>
+            <a:r>
+              <a:rPr lang="en-US" sz="1300" dirty="0">
+                <a:solidFill>
+                  <a:schemeClr val="bg1"/>
+                </a:solidFill>
+              </a:rPr>
+              <a:t>2〜3カ月の診断へ</a:t>
+            </a:r>
+            <a:endParaRPr lang="en-US" sz="2000" dirty="0"/>
+          </a:p>
+        </p:txBody>
+      </p:sp>
+      <p:sp>
+        <p:nvSpPr>
+          <p:cNvPr id="32" name="Text 30"/>
+          <p:cNvSpPr txBox="1"/>
+          <p:nvPr/>
+        </p:nvSpPr>
+        <p:spPr>
+          <a:xfrm>
+            <a:off x="548640" y="5440680"/>
+            <a:ext cx="11064240" cy="731520"/>
           </a:xfrm>
           <a:prstGeom prst="rect">
             <a:avLst/>
@@ -4324,594 +4965,12 @@
               <a:buNone/>
             </a:pPr>
             <a:r>
-              <a:rPr lang="en-US" sz="1800" b="1" dirty="0">
-                <a:solidFill>
-                  <a:schemeClr val="tx1"/>
-                </a:solidFill>
-              </a:rPr>
-              <a:t>ホワイトペーパー</a:t>
-            </a:r>
-            <a:endParaRPr lang="en-US" sz="1800" dirty="0"/>
-          </a:p>
-        </p:txBody>
-      </p:sp>
-      <p:sp>
-        <p:nvSpPr>
-          <p:cNvPr id="14" name="Text 12"/>
-          <p:cNvSpPr txBox="1"/>
-          <p:nvPr/>
-        </p:nvSpPr>
-        <p:spPr>
-          <a:xfrm>
-            <a:off x="3611880" y="3520440"/>
-            <a:ext cx="2103120" cy="822960"/>
-          </a:xfrm>
-          <a:prstGeom prst="rect">
-            <a:avLst/>
-          </a:prstGeom>
-          <a:noFill/>
-          <a:ln/>
-        </p:spPr>
-        <p:txBody>
-          <a:bodyPr wrap="square" lIns="0" tIns="0" rIns="0" bIns="0" rtlCol="0" anchor="t"/>
-          <a:lstStyle/>
-          <a:p>
-            <a:pPr indent="0" marL="0">
-              <a:buNone/>
-            </a:pPr>
-            <a:r>
-              <a:rPr lang="en-US" sz="1400" dirty="0">
-                <a:solidFill>
-                  <a:schemeClr val="tx1"/>
-                </a:solidFill>
-              </a:rPr>
-              <a:t>10分のセルフチェックで現在地を知る</a:t>
-            </a:r>
-            <a:endParaRPr lang="en-US" sz="1400" dirty="0"/>
-          </a:p>
-        </p:txBody>
-      </p:sp>
-      <p:sp>
-        <p:nvSpPr>
-          <p:cNvPr id="15" name="Text 13"/>
-          <p:cNvSpPr txBox="1"/>
-          <p:nvPr/>
-        </p:nvSpPr>
-        <p:spPr>
-          <a:xfrm>
-            <a:off x="3611880" y="4389120"/>
-            <a:ext cx="2103120" cy="548640"/>
-          </a:xfrm>
-          <a:prstGeom prst="rect">
-            <a:avLst/>
-          </a:prstGeom>
-          <a:noFill/>
-          <a:ln/>
-        </p:spPr>
-        <p:txBody>
-          <a:bodyPr wrap="square" lIns="0" tIns="0" rIns="0" bIns="0" rtlCol="0" anchor="t"/>
-          <a:lstStyle/>
-          <a:p>
-            <a:pPr indent="0" marL="0">
-              <a:buNone/>
-            </a:pPr>
-            <a:r>
-              <a:rPr lang="en-US" sz="1200" dirty="0">
-                <a:solidFill>
-                  <a:schemeClr val="accent5"/>
-                </a:solidFill>
-              </a:rPr>
-              <a:t>指標：ダウンロード数</a:t>
-            </a:r>
-            <a:endParaRPr lang="en-US" sz="1200" dirty="0"/>
-          </a:p>
-        </p:txBody>
-      </p:sp>
-      <p:sp>
-        <p:nvSpPr>
-          <p:cNvPr id="16" name="Arrow"/>
-          <p:cNvSpPr/>
-          <p:nvPr/>
-        </p:nvSpPr>
-        <p:spPr>
-          <a:xfrm>
-            <a:off x="5961888" y="3200400"/>
-            <a:ext cx="237744" cy="365760"/>
-          </a:xfrm>
-          <a:prstGeom prst="rightArrow">
-            <a:avLst/>
-          </a:prstGeom>
-          <a:solidFill>
-            <a:schemeClr val="accent5"/>
-          </a:solidFill>
-          <a:ln w="12700">
-            <a:solidFill>
-              <a:schemeClr val="accent5"/>
-            </a:solidFill>
-            <a:prstDash val="solid"/>
-          </a:ln>
-        </p:spPr>
-      </p:sp>
-      <p:sp>
-        <p:nvSpPr>
-          <p:cNvPr id="17" name="Step"/>
-          <p:cNvSpPr/>
-          <p:nvPr/>
-        </p:nvSpPr>
-        <p:spPr>
-          <a:xfrm>
-            <a:off x="6217920" y="1737360"/>
-            <a:ext cx="2560320" cy="3291840"/>
-          </a:xfrm>
-          <a:prstGeom prst="rect">
-            <a:avLst/>
-          </a:prstGeom>
-          <a:solidFill>
-            <a:schemeClr val="bg2"/>
-          </a:solidFill>
-          <a:ln w="12700">
-            <a:solidFill>
-              <a:schemeClr val="bg2"/>
-            </a:solidFill>
-            <a:prstDash val="solid"/>
-          </a:ln>
-        </p:spPr>
-      </p:sp>
-      <p:sp>
-        <p:nvSpPr>
-          <p:cNvPr id="18" name="Badge"/>
-          <p:cNvSpPr/>
-          <p:nvPr/>
-        </p:nvSpPr>
-        <p:spPr>
-          <a:xfrm>
-            <a:off x="6446520" y="1965960"/>
-            <a:ext cx="548640" cy="548640"/>
-          </a:xfrm>
-          <a:prstGeom prst="ellipse">
-            <a:avLst/>
-          </a:prstGeom>
-          <a:solidFill>
-            <a:schemeClr val="accent1"/>
-          </a:solidFill>
-          <a:ln w="12700">
-            <a:solidFill>
-              <a:schemeClr val="accent1"/>
-            </a:solidFill>
-            <a:prstDash val="solid"/>
-          </a:ln>
-        </p:spPr>
-      </p:sp>
-      <p:sp>
-        <p:nvSpPr>
-          <p:cNvPr id="19" name="Text 17"/>
-          <p:cNvSpPr txBox="1"/>
-          <p:nvPr/>
-        </p:nvSpPr>
-        <p:spPr>
-          <a:xfrm>
-            <a:off x="6446520" y="1965960"/>
-            <a:ext cx="548640" cy="548640"/>
-          </a:xfrm>
-          <a:prstGeom prst="rect">
-            <a:avLst/>
-          </a:prstGeom>
-          <a:noFill/>
-          <a:ln/>
-        </p:spPr>
-        <p:txBody>
-          <a:bodyPr wrap="square" lIns="0" tIns="0" rIns="0" bIns="0" rtlCol="0" anchor="ctr"/>
-          <a:lstStyle/>
-          <a:p>
-            <a:pPr algn="ctr" indent="0" marL="0">
-              <a:buNone/>
-            </a:pPr>
-            <a:r>
-              <a:rPr lang="en-US" sz="1800" b="1" dirty="0">
-                <a:solidFill>
-                  <a:schemeClr val="bg1"/>
-                </a:solidFill>
-              </a:rPr>
-              <a:t>3</a:t>
-            </a:r>
-            <a:endParaRPr lang="en-US" sz="1800" dirty="0"/>
-          </a:p>
-        </p:txBody>
-      </p:sp>
-      <p:sp>
-        <p:nvSpPr>
-          <p:cNvPr id="20" name="Text 18"/>
-          <p:cNvSpPr txBox="1"/>
-          <p:nvPr/>
-        </p:nvSpPr>
-        <p:spPr>
-          <a:xfrm>
-            <a:off x="6446520" y="2743200"/>
-            <a:ext cx="2103120" cy="731520"/>
-          </a:xfrm>
-          <a:prstGeom prst="rect">
-            <a:avLst/>
-          </a:prstGeom>
-          <a:noFill/>
-          <a:ln/>
-        </p:spPr>
-        <p:txBody>
-          <a:bodyPr wrap="square" lIns="0" tIns="0" rIns="0" bIns="0" rtlCol="0" anchor="t"/>
-          <a:lstStyle/>
-          <a:p>
-            <a:pPr indent="0" marL="0">
-              <a:buNone/>
-            </a:pPr>
-            <a:r>
-              <a:rPr lang="en-US" sz="1800" b="1" dirty="0">
-                <a:solidFill>
-                  <a:schemeClr val="tx1"/>
-                </a:solidFill>
-              </a:rPr>
-              <a:t>結果の読み合わせ</a:t>
-            </a:r>
-            <a:endParaRPr lang="en-US" sz="1800" dirty="0"/>
-          </a:p>
-        </p:txBody>
-      </p:sp>
-      <p:sp>
-        <p:nvSpPr>
-          <p:cNvPr id="21" name="Text 19"/>
-          <p:cNvSpPr txBox="1"/>
-          <p:nvPr/>
-        </p:nvSpPr>
-        <p:spPr>
-          <a:xfrm>
-            <a:off x="6446520" y="3520440"/>
-            <a:ext cx="2103120" cy="822960"/>
-          </a:xfrm>
-          <a:prstGeom prst="rect">
-            <a:avLst/>
-          </a:prstGeom>
-          <a:noFill/>
-          <a:ln/>
-        </p:spPr>
-        <p:txBody>
-          <a:bodyPr wrap="square" lIns="0" tIns="0" rIns="0" bIns="0" rtlCol="0" anchor="t"/>
-          <a:lstStyle/>
-          <a:p>
-            <a:pPr indent="0" marL="0">
-              <a:buNone/>
-            </a:pPr>
-            <a:r>
-              <a:rPr lang="en-US" sz="1400" dirty="0">
-                <a:solidFill>
-                  <a:schemeClr val="tx1"/>
-                </a:solidFill>
-              </a:rPr>
-              <a:t>NOだった項目を30分で一緒に確認</a:t>
-            </a:r>
-            <a:endParaRPr lang="en-US" sz="1400" dirty="0"/>
-          </a:p>
-        </p:txBody>
-      </p:sp>
-      <p:sp>
-        <p:nvSpPr>
-          <p:cNvPr id="22" name="Text 20"/>
-          <p:cNvSpPr txBox="1"/>
-          <p:nvPr/>
-        </p:nvSpPr>
-        <p:spPr>
-          <a:xfrm>
-            <a:off x="6446520" y="4389120"/>
-            <a:ext cx="2103120" cy="548640"/>
-          </a:xfrm>
-          <a:prstGeom prst="rect">
-            <a:avLst/>
-          </a:prstGeom>
-          <a:noFill/>
-          <a:ln/>
-        </p:spPr>
-        <p:txBody>
-          <a:bodyPr wrap="square" lIns="0" tIns="0" rIns="0" bIns="0" rtlCol="0" anchor="t"/>
-          <a:lstStyle/>
-          <a:p>
-            <a:pPr indent="0" marL="0">
-              <a:buNone/>
-            </a:pPr>
-            <a:r>
-              <a:rPr lang="en-US" sz="1200" dirty="0">
-                <a:solidFill>
-                  <a:schemeClr val="accent5"/>
-                </a:solidFill>
-              </a:rPr>
-              <a:t>指標：実施率</a:t>
-            </a:r>
-            <a:endParaRPr lang="en-US" sz="1200" dirty="0"/>
-          </a:p>
-        </p:txBody>
-      </p:sp>
-      <p:sp>
-        <p:nvSpPr>
-          <p:cNvPr id="23" name="Arrow"/>
-          <p:cNvSpPr/>
-          <p:nvPr/>
-        </p:nvSpPr>
-        <p:spPr>
-          <a:xfrm>
-            <a:off x="8796528" y="3200400"/>
-            <a:ext cx="237744" cy="365760"/>
-          </a:xfrm>
-          <a:prstGeom prst="rightArrow">
-            <a:avLst/>
-          </a:prstGeom>
-          <a:solidFill>
-            <a:schemeClr val="accent5"/>
-          </a:solidFill>
-          <a:ln w="12700">
-            <a:solidFill>
-              <a:schemeClr val="accent5"/>
-            </a:solidFill>
-            <a:prstDash val="solid"/>
-          </a:ln>
-        </p:spPr>
-      </p:sp>
-      <p:sp>
-        <p:nvSpPr>
-          <p:cNvPr id="24" name="Step"/>
-          <p:cNvSpPr/>
-          <p:nvPr/>
-        </p:nvSpPr>
-        <p:spPr>
-          <a:xfrm>
-            <a:off x="9052560" y="1737360"/>
-            <a:ext cx="2560320" cy="3291840"/>
-          </a:xfrm>
-          <a:prstGeom prst="rect">
-            <a:avLst/>
-          </a:prstGeom>
-          <a:solidFill>
-            <a:schemeClr val="accent1"/>
-          </a:solidFill>
-          <a:ln w="12700">
-            <a:solidFill>
-              <a:schemeClr val="accent1"/>
-            </a:solidFill>
-            <a:prstDash val="solid"/>
-          </a:ln>
-        </p:spPr>
-      </p:sp>
-      <p:sp>
-        <p:nvSpPr>
-          <p:cNvPr id="25" name="Badge"/>
-          <p:cNvSpPr/>
-          <p:nvPr/>
-        </p:nvSpPr>
-        <p:spPr>
-          <a:xfrm>
-            <a:off x="9281160" y="1965960"/>
-            <a:ext cx="548640" cy="548640"/>
-          </a:xfrm>
-          <a:prstGeom prst="ellipse">
-            <a:avLst/>
-          </a:prstGeom>
-          <a:solidFill>
-            <a:schemeClr val="bg1"/>
-          </a:solidFill>
-          <a:ln w="12700">
-            <a:solidFill>
-              <a:schemeClr val="bg1"/>
-            </a:solidFill>
-            <a:prstDash val="solid"/>
-          </a:ln>
-        </p:spPr>
-      </p:sp>
-      <p:sp>
-        <p:nvSpPr>
-          <p:cNvPr id="26" name="Text 24"/>
-          <p:cNvSpPr txBox="1"/>
-          <p:nvPr/>
-        </p:nvSpPr>
-        <p:spPr>
-          <a:xfrm>
-            <a:off x="9281160" y="1965960"/>
-            <a:ext cx="548640" cy="548640"/>
-          </a:xfrm>
-          <a:prstGeom prst="rect">
-            <a:avLst/>
-          </a:prstGeom>
-          <a:noFill/>
-          <a:ln/>
-        </p:spPr>
-        <p:txBody>
-          <a:bodyPr wrap="square" lIns="0" tIns="0" rIns="0" bIns="0" rtlCol="0" anchor="ctr"/>
-          <a:lstStyle/>
-          <a:p>
-            <a:pPr algn="ctr" indent="0" marL="0">
-              <a:buNone/>
-            </a:pPr>
-            <a:r>
-              <a:rPr lang="en-US" sz="1800" b="1" dirty="0">
-                <a:solidFill>
-                  <a:schemeClr val="bg1"/>
-                </a:solidFill>
-              </a:rPr>
-              <a:t>4</a:t>
-            </a:r>
-            <a:endParaRPr lang="en-US" sz="1800" dirty="0"/>
-          </a:p>
-        </p:txBody>
-      </p:sp>
-      <p:sp>
-        <p:nvSpPr>
-          <p:cNvPr id="27" name="Text 25"/>
-          <p:cNvSpPr txBox="1"/>
-          <p:nvPr/>
-        </p:nvSpPr>
-        <p:spPr>
-          <a:xfrm>
-            <a:off x="9281160" y="1965960"/>
-            <a:ext cx="548640" cy="548640"/>
-          </a:xfrm>
-          <a:prstGeom prst="rect">
-            <a:avLst/>
-          </a:prstGeom>
-          <a:noFill/>
-          <a:ln/>
-        </p:spPr>
-        <p:txBody>
-          <a:bodyPr wrap="square" lIns="0" tIns="0" rIns="0" bIns="0" rtlCol="0" anchor="ctr"/>
-          <a:lstStyle/>
-          <a:p>
-            <a:pPr algn="ctr" indent="0" marL="0">
-              <a:buNone/>
-            </a:pPr>
-            <a:r>
-              <a:rPr lang="en-US" sz="1800" b="1" dirty="0">
-                <a:solidFill>
-                  <a:schemeClr val="accent1"/>
-                </a:solidFill>
-              </a:rPr>
-              <a:t>4</a:t>
-            </a:r>
-            <a:endParaRPr lang="en-US" sz="1800" dirty="0"/>
-          </a:p>
-        </p:txBody>
-      </p:sp>
-      <p:sp>
-        <p:nvSpPr>
-          <p:cNvPr id="28" name="Text 26"/>
-          <p:cNvSpPr txBox="1"/>
-          <p:nvPr/>
-        </p:nvSpPr>
-        <p:spPr>
-          <a:xfrm>
-            <a:off x="9281160" y="2743200"/>
-            <a:ext cx="2103120" cy="731520"/>
-          </a:xfrm>
-          <a:prstGeom prst="rect">
-            <a:avLst/>
-          </a:prstGeom>
-          <a:noFill/>
-          <a:ln/>
-        </p:spPr>
-        <p:txBody>
-          <a:bodyPr wrap="square" lIns="0" tIns="0" rIns="0" bIns="0" rtlCol="0" anchor="t"/>
-          <a:lstStyle/>
-          <a:p>
-            <a:pPr indent="0" marL="0">
-              <a:buNone/>
-            </a:pPr>
-            <a:r>
-              <a:rPr lang="en-US" sz="1800" b="1" dirty="0">
-                <a:solidFill>
-                  <a:schemeClr val="bg1"/>
-                </a:solidFill>
-              </a:rPr>
-              <a:t>IT診断サービス</a:t>
-            </a:r>
-            <a:endParaRPr lang="en-US" sz="1800" dirty="0"/>
-          </a:p>
-        </p:txBody>
-      </p:sp>
-      <p:sp>
-        <p:nvSpPr>
-          <p:cNvPr id="29" name="Text 27"/>
-          <p:cNvSpPr txBox="1"/>
-          <p:nvPr/>
-        </p:nvSpPr>
-        <p:spPr>
-          <a:xfrm>
-            <a:off x="9281160" y="3520440"/>
-            <a:ext cx="2103120" cy="822960"/>
-          </a:xfrm>
-          <a:prstGeom prst="rect">
-            <a:avLst/>
-          </a:prstGeom>
-          <a:noFill/>
-          <a:ln/>
-        </p:spPr>
-        <p:txBody>
-          <a:bodyPr wrap="square" lIns="0" tIns="0" rIns="0" bIns="0" rtlCol="0" anchor="t"/>
-          <a:lstStyle/>
-          <a:p>
-            <a:pPr indent="0" marL="0">
-              <a:buNone/>
-            </a:pPr>
-            <a:r>
-              <a:rPr lang="en-US" sz="1400" dirty="0">
-                <a:solidFill>
-                  <a:schemeClr val="bg1"/>
-                </a:solidFill>
-              </a:rPr>
-              <a:t>2〜3カ月の診断へ進む</a:t>
-            </a:r>
-            <a:endParaRPr lang="en-US" sz="1400" dirty="0"/>
-          </a:p>
-        </p:txBody>
-      </p:sp>
-      <p:sp>
-        <p:nvSpPr>
-          <p:cNvPr id="30" name="Text 28"/>
-          <p:cNvSpPr txBox="1"/>
-          <p:nvPr/>
-        </p:nvSpPr>
-        <p:spPr>
-          <a:xfrm>
-            <a:off x="9281160" y="4389120"/>
-            <a:ext cx="2103120" cy="548640"/>
-          </a:xfrm>
-          <a:prstGeom prst="rect">
-            <a:avLst/>
-          </a:prstGeom>
-          <a:noFill/>
-          <a:ln/>
-        </p:spPr>
-        <p:txBody>
-          <a:bodyPr wrap="square" lIns="0" tIns="0" rIns="0" bIns="0" rtlCol="0" anchor="t"/>
-          <a:lstStyle/>
-          <a:p>
-            <a:pPr indent="0" marL="0">
-              <a:buNone/>
-            </a:pPr>
-            <a:r>
-              <a:rPr lang="en-US" sz="1200" dirty="0">
-                <a:solidFill>
-                  <a:schemeClr val="accent6"/>
-                </a:solidFill>
-              </a:rPr>
-              <a:t>指標：商談化数</a:t>
-            </a:r>
-            <a:endParaRPr lang="en-US" sz="1200" dirty="0"/>
-          </a:p>
-        </p:txBody>
-      </p:sp>
-      <p:sp>
-        <p:nvSpPr>
-          <p:cNvPr id="31" name="Text 29"/>
-          <p:cNvSpPr txBox="1"/>
-          <p:nvPr/>
-        </p:nvSpPr>
-        <p:spPr>
-          <a:xfrm>
-            <a:off x="548640" y="5394960"/>
-            <a:ext cx="11064240" cy="640080"/>
-          </a:xfrm>
-          <a:prstGeom prst="rect">
-            <a:avLst/>
-          </a:prstGeom>
-          <a:noFill/>
-          <a:ln/>
-        </p:spPr>
-        <p:txBody>
-          <a:bodyPr wrap="square" lIns="0" tIns="0" rIns="0" bIns="0" rtlCol="0" anchor="t"/>
-          <a:lstStyle/>
-          <a:p>
-            <a:pPr indent="0" marL="0">
-              <a:buNone/>
-            </a:pPr>
-            <a:r>
               <a:rPr lang="en-US" sz="1600" b="1" dirty="0">
                 <a:solidFill>
                   <a:schemeClr val="tx2"/>
                 </a:solidFill>
               </a:rPr>
-              <a:t>営業が使える社内用の版（NO項目＝診断の仮説）も同時に用意し、問い合わせ前の会話にも使えるようにします。</a:t>
+              <a:t>同じホワイトペーパーを、Webでは集客に、営業の場では会話の道具に使います。営業用の版（NO項目＝診断の仮説）も用意します。</a:t>
             </a:r>
             <a:endParaRPr lang="en-US" sz="1600" dirty="0"/>
           </a:p>
@@ -6937,7 +6996,7 @@
                   <a:schemeClr val="tx1"/>
                 </a:solidFill>
               </a:rPr>
-              <a:t>出力：軸別スコアと判定</a:t>
+              <a:t>出力：総合スコアと軸別の内訳</a:t>
             </a:r>
             <a:endParaRPr lang="en-US" sz="1500" dirty="0"/>
           </a:p>
@@ -7061,7 +7120,7 @@
                   <a:schemeClr val="tx1"/>
                 </a:solidFill>
               </a:rPr>
-              <a:t>チェックリストはYES/NOで答え、軸別に点数化する</a:t>
+              <a:t>YES/NOで答え、総合スコアと内訳で見せる</a:t>
             </a:r>
             <a:endParaRPr lang="en-US" sz="2800" dirty="0"/>
           </a:p>
@@ -7366,7 +7425,7 @@
         </p:nvSpPr>
         <p:spPr>
           <a:xfrm>
-            <a:off x="548640" y="2971800"/>
+            <a:off x="548640" y="2926080"/>
             <a:ext cx="5486400" cy="411480"/>
           </a:xfrm>
           <a:prstGeom prst="rect">
@@ -7388,7 +7447,7 @@
                   <a:schemeClr val="tx2"/>
                 </a:solidFill>
               </a:rPr>
-              <a:t>軸ごとの判定（各7点満点）</a:t>
+              <a:t>総合スコアの判定（21点満点）</a:t>
             </a:r>
             <a:endParaRPr lang="en-US" sz="1800" dirty="0"/>
           </a:p>
@@ -7402,8 +7461,8 @@
         </p:nvSpPr>
         <p:spPr>
           <a:xfrm>
-            <a:off x="548640" y="3474720"/>
-            <a:ext cx="1783080" cy="1280160"/>
+            <a:off x="548640" y="3429000"/>
+            <a:ext cx="1783080" cy="1097280"/>
           </a:xfrm>
           <a:prstGeom prst="rect">
             <a:avLst/>
@@ -7427,7 +7486,7 @@
         </p:nvSpPr>
         <p:spPr>
           <a:xfrm>
-            <a:off x="548640" y="3566160"/>
+            <a:off x="548640" y="3474720"/>
             <a:ext cx="1783080" cy="548640"/>
           </a:xfrm>
           <a:prstGeom prst="rect">
@@ -7449,7 +7508,7 @@
                   <a:schemeClr val="tx1"/>
                 </a:solidFill>
               </a:rPr>
-              <a:t>5〜7点</a:t>
+              <a:t>17〜21点</a:t>
             </a:r>
             <a:endParaRPr lang="en-US" sz="2000" dirty="0"/>
           </a:p>
@@ -7463,7 +7522,7 @@
         </p:nvSpPr>
         <p:spPr>
           <a:xfrm>
-            <a:off x="548640" y="4114800"/>
+            <a:off x="548640" y="3977640"/>
             <a:ext cx="1783080" cy="457200"/>
           </a:xfrm>
           <a:prstGeom prst="rect">
@@ -7499,8 +7558,8 @@
         </p:nvSpPr>
         <p:spPr>
           <a:xfrm>
-            <a:off x="2468880" y="3474720"/>
-            <a:ext cx="1783080" cy="1280160"/>
+            <a:off x="2468880" y="3429000"/>
+            <a:ext cx="1783080" cy="1097280"/>
           </a:xfrm>
           <a:prstGeom prst="rect">
             <a:avLst/>
@@ -7524,7 +7583,7 @@
         </p:nvSpPr>
         <p:spPr>
           <a:xfrm>
-            <a:off x="2468880" y="3566160"/>
+            <a:off x="2468880" y="3474720"/>
             <a:ext cx="1783080" cy="548640"/>
           </a:xfrm>
           <a:prstGeom prst="rect">
@@ -7546,7 +7605,7 @@
                   <a:schemeClr val="bg1"/>
                 </a:solidFill>
               </a:rPr>
-              <a:t>3〜4点</a:t>
+              <a:t>11〜16点</a:t>
             </a:r>
             <a:endParaRPr lang="en-US" sz="2000" dirty="0"/>
           </a:p>
@@ -7560,7 +7619,7 @@
         </p:nvSpPr>
         <p:spPr>
           <a:xfrm>
-            <a:off x="2468880" y="4114800"/>
+            <a:off x="2468880" y="3977640"/>
             <a:ext cx="1783080" cy="457200"/>
           </a:xfrm>
           <a:prstGeom prst="rect">
@@ -7596,8 +7655,8 @@
         </p:nvSpPr>
         <p:spPr>
           <a:xfrm>
-            <a:off x="4389120" y="3474720"/>
-            <a:ext cx="1783080" cy="1280160"/>
+            <a:off x="4389120" y="3429000"/>
+            <a:ext cx="1783080" cy="1097280"/>
           </a:xfrm>
           <a:prstGeom prst="rect">
             <a:avLst/>
@@ -7621,7 +7680,7 @@
         </p:nvSpPr>
         <p:spPr>
           <a:xfrm>
-            <a:off x="4389120" y="3566160"/>
+            <a:off x="4389120" y="3474720"/>
             <a:ext cx="1783080" cy="548640"/>
           </a:xfrm>
           <a:prstGeom prst="rect">
@@ -7643,7 +7702,7 @@
                   <a:schemeClr val="bg1"/>
                 </a:solidFill>
               </a:rPr>
-              <a:t>0〜2点</a:t>
+              <a:t>0〜10点</a:t>
             </a:r>
             <a:endParaRPr lang="en-US" sz="2000" dirty="0"/>
           </a:p>
@@ -7657,7 +7716,7 @@
         </p:nvSpPr>
         <p:spPr>
           <a:xfrm>
-            <a:off x="4389120" y="4114800"/>
+            <a:off x="4389120" y="3977640"/>
             <a:ext cx="1783080" cy="457200"/>
           </a:xfrm>
           <a:prstGeom prst="rect">
@@ -7687,14 +7746,89 @@
       </p:sp>
       <p:sp>
         <p:nvSpPr>
-          <p:cNvPr id="22" name="Text 20"/>
-          <p:cNvSpPr txBox="1"/>
-          <p:nvPr/>
-        </p:nvSpPr>
-        <p:spPr>
-          <a:xfrm>
-            <a:off x="548640" y="4937760"/>
-            <a:ext cx="5669280" cy="457200"/>
+          <p:cNvPr id="22" name="Example"/>
+          <p:cNvSpPr/>
+          <p:nvPr/>
+        </p:nvSpPr>
+        <p:spPr>
+          <a:xfrm>
+            <a:off x="548640" y="4709160"/>
+            <a:ext cx="5669280" cy="1005840"/>
+          </a:xfrm>
+          <a:prstGeom prst="rect">
+            <a:avLst/>
+          </a:prstGeom>
+          <a:solidFill>
+            <a:srgbClr val="FFFFFF"/>
+          </a:solidFill>
+          <a:ln w="12700">
+            <a:solidFill>
+              <a:schemeClr val="accent6"/>
+            </a:solidFill>
+            <a:prstDash val="solid"/>
+          </a:ln>
+        </p:spPr>
+      </p:sp>
+      <p:sp>
+        <p:nvSpPr>
+          <p:cNvPr id="23" name="Text 21"/>
+          <p:cNvSpPr txBox="1"/>
+          <p:nvPr/>
+        </p:nvSpPr>
+        <p:spPr>
+          <a:xfrm>
+            <a:off x="731520" y="4754880"/>
+            <a:ext cx="5303520" cy="914400"/>
+          </a:xfrm>
+          <a:prstGeom prst="rect">
+            <a:avLst/>
+          </a:prstGeom>
+          <a:noFill/>
+          <a:ln/>
+        </p:spPr>
+        <p:txBody>
+          <a:bodyPr wrap="square" lIns="0" tIns="0" rIns="0" bIns="0" rtlCol="0" anchor="ctr"/>
+          <a:lstStyle/>
+          <a:p>
+            <a:pPr indent="0" marL="0">
+              <a:buNone/>
+            </a:pPr>
+            <a:r>
+              <a:rPr lang="en-US" sz="1400" b="1" dirty="0">
+                <a:solidFill>
+                  <a:schemeClr val="accent1"/>
+                </a:solidFill>
+              </a:rPr>
+              <a:t>結果の見え方（例）</a:t>
+            </a:r>
+            <a:endParaRPr lang="en-US" sz="1400" dirty="0"/>
+          </a:p>
+          <a:p>
+            <a:pPr indent="0" marL="0">
+              <a:buNone/>
+            </a:pPr>
+            <a:r>
+              <a:rPr lang="en-US" sz="1400" dirty="0">
+                <a:solidFill>
+                  <a:schemeClr val="tx1"/>
+                </a:solidFill>
+              </a:rPr>
+              <a:t>総合 12点／21点（要注意）。内訳は、投資 3/7、リスク 5/7、競争力 4/7</a:t>
+            </a:r>
+            <a:endParaRPr lang="en-US" sz="1400" dirty="0"/>
+          </a:p>
+        </p:txBody>
+      </p:sp>
+      <p:sp>
+        <p:nvSpPr>
+          <p:cNvPr id="24" name="Text 22"/>
+          <p:cNvSpPr txBox="1"/>
+          <p:nvPr/>
+        </p:nvSpPr>
+        <p:spPr>
+          <a:xfrm>
+            <a:off x="548640" y="5806440"/>
+            <a:ext cx="5669280" cy="365760"/>
           </a:xfrm>
           <a:prstGeom prst="rect">
             <a:avLst/>
@@ -7723,14 +7857,14 @@
       </p:sp>
       <p:sp>
         <p:nvSpPr>
-          <p:cNvPr id="23" name="Card"/>
+          <p:cNvPr id="25" name="Card"/>
           <p:cNvSpPr/>
           <p:nvPr/>
         </p:nvSpPr>
         <p:spPr>
           <a:xfrm>
-            <a:off x="6400800" y="2971800"/>
-            <a:ext cx="5212080" cy="3108960"/>
+            <a:off x="6400800" y="2926080"/>
+            <a:ext cx="5212080" cy="3246120"/>
           </a:xfrm>
           <a:prstGeom prst="rect">
             <a:avLst/>
@@ -7748,13 +7882,13 @@
       </p:sp>
       <p:sp>
         <p:nvSpPr>
-          <p:cNvPr id="24" name="Text 22"/>
-          <p:cNvSpPr txBox="1"/>
-          <p:nvPr/>
-        </p:nvSpPr>
-        <p:spPr>
-          <a:xfrm>
-            <a:off x="6629400" y="3108960"/>
+          <p:cNvPr id="26" name="Text 24"/>
+          <p:cNvSpPr txBox="1"/>
+          <p:nvPr/>
+        </p:nvSpPr>
+        <p:spPr>
+          <a:xfrm>
+            <a:off x="6629400" y="3063240"/>
             <a:ext cx="4754880" cy="457200"/>
           </a:xfrm>
           <a:prstGeom prst="rect">
@@ -7784,14 +7918,14 @@
       </p:sp>
       <p:sp>
         <p:nvSpPr>
-          <p:cNvPr id="25" name="Text 23"/>
-          <p:cNvSpPr txBox="1"/>
-          <p:nvPr/>
-        </p:nvSpPr>
-        <p:spPr>
-          <a:xfrm>
-            <a:off x="6629400" y="3657600"/>
-            <a:ext cx="4754880" cy="2286000"/>
+          <p:cNvPr id="27" name="Text 25"/>
+          <p:cNvSpPr txBox="1"/>
+          <p:nvPr/>
+        </p:nvSpPr>
+        <p:spPr>
+          <a:xfrm>
+            <a:off x="6629400" y="3611880"/>
+            <a:ext cx="4754880" cy="2423160"/>
           </a:xfrm>
           <a:prstGeom prst="rect">
             <a:avLst/>
@@ -7834,7 +7968,7 @@
                   <a:schemeClr val="tx1"/>
                 </a:solidFill>
               </a:rPr>
-              <a:t>見せるのは合計点より軸別の結果。何が弱いかが分かる</a:t>
+              <a:t>まず総合スコアで現在地を一言で伝え、軸別の内訳で弱い所を示す</a:t>
             </a:r>
             <a:endParaRPr lang="en-US" sz="1400" dirty="0"/>
           </a:p>
@@ -8861,10 +8995,10 @@
             <a:tbl>
               <a:tblPr/>
               <a:tblGrid>
-                <a:gridCol w="548640"/>
-                <a:gridCol w="1097280"/>
-                <a:gridCol w="6035040"/>
-                <a:gridCol w="3383280"/>
+                <a:gridCol w="457200"/>
+                <a:gridCol w="914400"/>
+                <a:gridCol w="4846320"/>
+                <a:gridCol w="4846320"/>
               </a:tblGrid>
               <a:tr h="457200">
                 <a:tc>
@@ -9064,7 +9198,7 @@
                             <a:srgbClr val="FFFFFF"/>
                           </a:solidFill>
                         </a:rPr>
-                        <a:t>狙う検索意図</a:t>
+                        <a:t>狙うキーワード（月間検索数）</a:t>
                       </a:r>
                       <a:endParaRPr lang="en-US" sz="1300" dirty="0"/>
                     </a:p>
@@ -9310,7 +9444,7 @@
                             <a:srgbClr val="333333"/>
                           </a:solidFill>
                         </a:rPr>
-                        <a:t>IT投資 効果測定、IT投資 ROI</a:t>
+                        <a:t>IT投資 250 ／ IT投資とは 150 ／ IT投資 事例 150</a:t>
                       </a:r>
                       <a:endParaRPr lang="en-US" sz="1300" dirty="0"/>
                     </a:p>
@@ -9556,7 +9690,7 @@
                             <a:srgbClr val="333333"/>
                           </a:solidFill>
                         </a:rPr>
-                        <a:t>IT投資計画、IT中期計画</a:t>
+                        <a:t>IT投資管理 70 ／ IT投資予算 60</a:t>
                       </a:r>
                       <a:endParaRPr lang="en-US" sz="1300" dirty="0"/>
                     </a:p>
@@ -9802,7 +9936,7 @@
                             <a:srgbClr val="333333"/>
                           </a:solidFill>
                         </a:rPr>
-                        <a:t>ITリスク 経営、IT統制</a:t>
+                        <a:t>IT統制 400 ／ IT全般統制 250 ／ ITリスク 100</a:t>
                       </a:r>
                       <a:endParaRPr lang="en-US" sz="1300" dirty="0"/>
                     </a:p>
@@ -10048,7 +10182,7 @@
                             <a:srgbClr val="333333"/>
                           </a:solidFill>
                         </a:rPr>
-                        <a:t>IT-BCP とは、システム停止 事業影響</a:t>
+                        <a:t>IT-BCP 700 ／ BCP システム 100</a:t>
                       </a:r>
                       <a:endParaRPr lang="en-US" sz="1300" dirty="0"/>
                     </a:p>
@@ -10294,7 +10428,7 @@
                             <a:srgbClr val="333333"/>
                           </a:solidFill>
                         </a:rPr>
-                        <a:t>DX 遅れ、DX 自社 評価</a:t>
+                        <a:t>DX 遅れ 100 ／ DX推進指標 100 ／ DX 日本 遅れ 40</a:t>
                       </a:r>
                       <a:endParaRPr lang="en-US" sz="1300" dirty="0"/>
                     </a:p>
@@ -10540,7 +10674,7 @@
                             <a:srgbClr val="333333"/>
                           </a:solidFill>
                         </a:rPr>
-                        <a:t>IT戦略 策定、IT戦略 経営戦略</a:t>
+                        <a:t>IT戦略 500 ／ IT戦略 策定 10</a:t>
                       </a:r>
                       <a:endParaRPr lang="en-US" sz="1300" dirty="0"/>
                     </a:p>
@@ -10786,7 +10920,7 @@
                             <a:srgbClr val="333333"/>
                           </a:solidFill>
                         </a:rPr>
-                        <a:t>IT診断 とは、IT診断 コンサル</a:t>
+                        <a:t>IT診断 60 ／ IT健康診断 10</a:t>
                       </a:r>
                       <a:endParaRPr lang="en-US" sz="1300" dirty="0"/>
                     </a:p>
@@ -10868,7 +11002,7 @@
                   <a:schemeClr val="tx2"/>
                 </a:solidFill>
               </a:rPr>
-              <a:t>各コラムの末尾に、該当軸の設問を2〜3問だけ抜粋して掲載し、WPの中身を想像できるようにします。検索意図は想定で、キーワード調査で検証します。</a:t>
+              <a:t>検索数はAhrefs（日本、2026年10月時点）。実施可否ではなく、タイトルとキーワードの選定に使います。各コラムの末尾に該当軸の設問を2〜3問抜粋し、WPの中身を想像できるようにします。</a:t>
             </a:r>
             <a:endParaRPr lang="en-US" sz="1300" dirty="0"/>
           </a:p>

</xml_diff>